<commit_message>
Add daily AI news collection: 2026-06-14
</commit_message>
<xml_diff>
--- a/data/2026-06-14.pptx
+++ b/data/2026-06-14.pptx
@@ -14,6 +14,7 @@
     <p:sldId id="262" r:id="rId13"/>
     <p:sldId id="263" r:id="rId14"/>
     <p:sldId id="264" r:id="rId15"/>
+    <p:sldId id="265" r:id="rId16"/>
   </p:sldIdLst>
   <p:sldSz cx="12188952" cy="6858000" type="screen4x3"/>
   <p:notesSz cx="6858000" cy="9144000"/>
@@ -3279,7 +3280,769 @@
                   <a:srgbClr val="85C1E9"/>
                 </a:solidFill>
               </a:rPr>
-              <a:t>総収集記事数：214 件</a:t>
+              <a:t>総収集記事数：215 件</a:t>
+            </a:r>
+          </a:p>
+        </p:txBody>
+      </p:sp>
+    </p:spTree>
+  </p:cSld>
+  <p:clrMapOvr>
+    <a:masterClrMapping/>
+  </p:clrMapOvr>
+</p:sld>
+</file>
+
+<file path=ppt/slides/slide10.xml><?xml version="1.0" encoding="utf-8"?>
+<p:sld xmlns:a="http://schemas.openxmlformats.org/drawingml/2006/main" xmlns:p="http://schemas.openxmlformats.org/presentationml/2006/main" xmlns:r="http://schemas.openxmlformats.org/officeDocument/2006/relationships">
+  <p:cSld>
+    <p:spTree>
+      <p:nvGrpSpPr>
+        <p:cNvPr id="1" name=""/>
+        <p:cNvGrpSpPr/>
+        <p:nvPr/>
+      </p:nvGrpSpPr>
+      <p:grpSpPr/>
+      <p:sp>
+        <p:nvSpPr>
+          <p:cNvPr id="2" name="Rectangle 1"/>
+          <p:cNvSpPr/>
+          <p:nvPr/>
+        </p:nvSpPr>
+        <p:spPr>
+          <a:xfrm>
+            <a:off x="0" y="0"/>
+            <a:ext cx="12188952" cy="960120"/>
+          </a:xfrm>
+          <a:prstGeom prst="rect">
+            <a:avLst/>
+          </a:prstGeom>
+          <a:solidFill>
+            <a:srgbClr val="2E86AB"/>
+          </a:solidFill>
+          <a:ln>
+            <a:noFill/>
+          </a:ln>
+        </p:spPr>
+        <p:style>
+          <a:lnRef idx="1">
+            <a:schemeClr val="accent1"/>
+          </a:lnRef>
+          <a:fillRef idx="3">
+            <a:schemeClr val="accent1"/>
+          </a:fillRef>
+          <a:effectRef idx="2">
+            <a:schemeClr val="accent1"/>
+          </a:effectRef>
+          <a:fontRef idx="minor">
+            <a:schemeClr val="lt1"/>
+          </a:fontRef>
+        </p:style>
+        <p:txBody>
+          <a:bodyPr rtlCol="0" anchor="ctr"/>
+          <a:lstStyle/>
+          <a:p>
+            <a:pPr algn="ctr"/>
+          </a:p>
+        </p:txBody>
+      </p:sp>
+      <p:sp>
+        <p:nvSpPr>
+          <p:cNvPr id="3" name="Rectangle 2"/>
+          <p:cNvSpPr/>
+          <p:nvPr/>
+        </p:nvSpPr>
+        <p:spPr>
+          <a:xfrm>
+            <a:off x="0" y="0"/>
+            <a:ext cx="137160" cy="960120"/>
+          </a:xfrm>
+          <a:prstGeom prst="rect">
+            <a:avLst/>
+          </a:prstGeom>
+          <a:solidFill>
+            <a:srgbClr val="55C500"/>
+          </a:solidFill>
+          <a:ln>
+            <a:noFill/>
+          </a:ln>
+        </p:spPr>
+        <p:style>
+          <a:lnRef idx="1">
+            <a:schemeClr val="accent1"/>
+          </a:lnRef>
+          <a:fillRef idx="3">
+            <a:schemeClr val="accent1"/>
+          </a:fillRef>
+          <a:effectRef idx="2">
+            <a:schemeClr val="accent1"/>
+          </a:effectRef>
+          <a:fontRef idx="minor">
+            <a:schemeClr val="lt1"/>
+          </a:fontRef>
+        </p:style>
+        <p:txBody>
+          <a:bodyPr rtlCol="0" anchor="ctr"/>
+          <a:lstStyle/>
+          <a:p>
+            <a:pPr algn="ctr"/>
+          </a:p>
+        </p:txBody>
+      </p:sp>
+      <p:sp>
+        <p:nvSpPr>
+          <p:cNvPr id="4" name="TextBox 3"/>
+          <p:cNvSpPr txBox="1"/>
+          <p:nvPr/>
+        </p:nvSpPr>
+        <p:spPr>
+          <a:xfrm>
+            <a:off x="274320" y="118872"/>
+            <a:ext cx="11612880" cy="749808"/>
+          </a:xfrm>
+          <a:prstGeom prst="rect">
+            <a:avLst/>
+          </a:prstGeom>
+          <a:noFill/>
+        </p:spPr>
+        <p:txBody>
+          <a:bodyPr wrap="square">
+            <a:spAutoFit/>
+          </a:bodyPr>
+          <a:lstStyle/>
+          <a:p>
+            <a:pPr algn="l"/>
+            <a:r>
+              <a:rPr sz="2400" b="1">
+                <a:solidFill>
+                  <a:srgbClr val="FFFFFF"/>
+                </a:solidFill>
+              </a:rPr>
+              <a:t>Qiita　記事一覧　(3 / 3)</a:t>
+            </a:r>
+          </a:p>
+        </p:txBody>
+      </p:sp>
+      <p:sp>
+        <p:nvSpPr>
+          <p:cNvPr id="5" name="TextBox 4"/>
+          <p:cNvSpPr txBox="1"/>
+          <p:nvPr/>
+        </p:nvSpPr>
+        <p:spPr>
+          <a:xfrm>
+            <a:off x="365760" y="6510528"/>
+            <a:ext cx="11430000" cy="320040"/>
+          </a:xfrm>
+          <a:prstGeom prst="rect">
+            <a:avLst/>
+          </a:prstGeom>
+          <a:noFill/>
+        </p:spPr>
+        <p:txBody>
+          <a:bodyPr wrap="square">
+            <a:spAutoFit/>
+          </a:bodyPr>
+          <a:lstStyle/>
+          <a:p>
+            <a:pPr algn="l"/>
+            <a:r>
+              <a:rPr sz="900" b="0">
+                <a:solidFill>
+                  <a:srgbClr val="7F8C8D"/>
+                </a:solidFill>
+              </a:rPr>
+              <a:t>※ 他 118 件は JSON アーカイブを参照</a:t>
+            </a:r>
+          </a:p>
+        </p:txBody>
+      </p:sp>
+      <p:sp>
+        <p:nvSpPr>
+          <p:cNvPr id="6" name="TextBox 5"/>
+          <p:cNvSpPr txBox="1"/>
+          <p:nvPr/>
+        </p:nvSpPr>
+        <p:spPr>
+          <a:xfrm>
+            <a:off x="365760" y="1024128"/>
+            <a:ext cx="11430000" cy="472379"/>
+          </a:xfrm>
+          <a:prstGeom prst="rect">
+            <a:avLst/>
+          </a:prstGeom>
+          <a:noFill/>
+        </p:spPr>
+        <p:txBody>
+          <a:bodyPr wrap="square">
+            <a:spAutoFit/>
+          </a:bodyPr>
+          <a:lstStyle/>
+          <a:p>
+            <a:r>
+              <a:rPr sz="1000">
+                <a:solidFill>
+                  <a:srgbClr val="55C500"/>
+                </a:solidFill>
+              </a:rPr>
+              <a:t>▶ </a:t>
+            </a:r>
+            <a:r>
+              <a:rPr sz="1200" b="1">
+                <a:solidFill>
+                  <a:srgbClr val="2C3E50"/>
+                </a:solidFill>
+              </a:rPr>
+              <a:t>Claude Codeのスキルが自動で発火しない本当の理由——未文書設定 skillListingMaxDescChars(既定1536字)を実機で確かめた</a:t>
+            </a:r>
+            <a:r>
+              <a:rPr sz="900">
+                <a:solidFill>
+                  <a:srgbClr val="7F8C8D"/>
+                </a:solidFill>
+              </a:rPr>
+              <a:t>  (2026-06-14)</a:t>
+            </a:r>
+          </a:p>
+        </p:txBody>
+      </p:sp>
+      <p:sp>
+        <p:nvSpPr>
+          <p:cNvPr id="7" name="TextBox 6"/>
+          <p:cNvSpPr txBox="1"/>
+          <p:nvPr/>
+        </p:nvSpPr>
+        <p:spPr>
+          <a:xfrm>
+            <a:off x="640080" y="1496507"/>
+            <a:ext cx="11155680" cy="269930"/>
+          </a:xfrm>
+          <a:prstGeom prst="rect">
+            <a:avLst/>
+          </a:prstGeom>
+          <a:noFill/>
+        </p:spPr>
+        <p:txBody>
+          <a:bodyPr wrap="none">
+            <a:spAutoFit/>
+          </a:bodyPr>
+          <a:lstStyle/>
+          <a:p>
+            <a:r>
+              <a:rPr sz="900">
+                <a:solidFill>
+                  <a:srgbClr val="216FD0"/>
+                </a:solidFill>
+                <a:hlinkClick r:id="rId2"/>
+              </a:rPr>
+              <a:t>https://qiita.com/yurukusa/items/2700b4d67f77220fa618</a:t>
+            </a:r>
+          </a:p>
+        </p:txBody>
+      </p:sp>
+      <p:sp>
+        <p:nvSpPr>
+          <p:cNvPr id="8" name="TextBox 7"/>
+          <p:cNvSpPr txBox="1"/>
+          <p:nvPr/>
+        </p:nvSpPr>
+        <p:spPr>
+          <a:xfrm>
+            <a:off x="640080" y="1766437"/>
+            <a:ext cx="11155680" cy="382402"/>
+          </a:xfrm>
+          <a:prstGeom prst="rect">
+            <a:avLst/>
+          </a:prstGeom>
+          <a:noFill/>
+        </p:spPr>
+        <p:txBody>
+          <a:bodyPr wrap="square">
+            <a:spAutoFit/>
+          </a:bodyPr>
+          <a:lstStyle/>
+          <a:p>
+            <a:r>
+              <a:rPr sz="900">
+                <a:solidFill>
+                  <a:srgbClr val="7F8C8D"/>
+                </a:solidFill>
+              </a:rPr>
+              <a:t>「スキルを作ったのに自動で起動しない」の本当の原因
+Claude Code でスキル(Skills)を自作したのに、いざ会話で関連する作業を頼んでも自動で発火しない。とくに日本語で話しかけると起動しない。こういう経験はないでしょうか。
+私(ゆるくさ)も同じ</a:t>
+            </a:r>
+          </a:p>
+        </p:txBody>
+      </p:sp>
+      <p:sp>
+        <p:nvSpPr>
+          <p:cNvPr id="9" name="TextBox 8"/>
+          <p:cNvSpPr txBox="1"/>
+          <p:nvPr/>
+        </p:nvSpPr>
+        <p:spPr>
+          <a:xfrm>
+            <a:off x="365760" y="2148840"/>
+            <a:ext cx="11430000" cy="472379"/>
+          </a:xfrm>
+          <a:prstGeom prst="rect">
+            <a:avLst/>
+          </a:prstGeom>
+          <a:noFill/>
+        </p:spPr>
+        <p:txBody>
+          <a:bodyPr wrap="square">
+            <a:spAutoFit/>
+          </a:bodyPr>
+          <a:lstStyle/>
+          <a:p>
+            <a:r>
+              <a:rPr sz="1000">
+                <a:solidFill>
+                  <a:srgbClr val="55C500"/>
+                </a:solidFill>
+              </a:rPr>
+              <a:t>▶ </a:t>
+            </a:r>
+            <a:r>
+              <a:rPr sz="1200" b="1">
+                <a:solidFill>
+                  <a:srgbClr val="2C3E50"/>
+                </a:solidFill>
+              </a:rPr>
+              <a:t>AIで対応速度を上げる前に、問い合わせ対応品質を測るシートをGASで作る</a:t>
+            </a:r>
+            <a:r>
+              <a:rPr sz="900">
+                <a:solidFill>
+                  <a:srgbClr val="7F8C8D"/>
+                </a:solidFill>
+              </a:rPr>
+              <a:t>  (2026-06-14)</a:t>
+            </a:r>
+          </a:p>
+        </p:txBody>
+      </p:sp>
+      <p:sp>
+        <p:nvSpPr>
+          <p:cNvPr id="10" name="TextBox 9"/>
+          <p:cNvSpPr txBox="1"/>
+          <p:nvPr/>
+        </p:nvSpPr>
+        <p:spPr>
+          <a:xfrm>
+            <a:off x="640080" y="2621219"/>
+            <a:ext cx="11155680" cy="269930"/>
+          </a:xfrm>
+          <a:prstGeom prst="rect">
+            <a:avLst/>
+          </a:prstGeom>
+          <a:noFill/>
+        </p:spPr>
+        <p:txBody>
+          <a:bodyPr wrap="none">
+            <a:spAutoFit/>
+          </a:bodyPr>
+          <a:lstStyle/>
+          <a:p>
+            <a:r>
+              <a:rPr sz="900">
+                <a:solidFill>
+                  <a:srgbClr val="216FD0"/>
+                </a:solidFill>
+                <a:hlinkClick r:id="rId3"/>
+              </a:rPr>
+              <a:t>https://qiita.com/Miraigent/items/371c99187f8c92aedbfe</a:t>
+            </a:r>
+          </a:p>
+        </p:txBody>
+      </p:sp>
+      <p:sp>
+        <p:nvSpPr>
+          <p:cNvPr id="11" name="TextBox 10"/>
+          <p:cNvSpPr txBox="1"/>
+          <p:nvPr/>
+        </p:nvSpPr>
+        <p:spPr>
+          <a:xfrm>
+            <a:off x="640080" y="2891149"/>
+            <a:ext cx="11155680" cy="382402"/>
+          </a:xfrm>
+          <a:prstGeom prst="rect">
+            <a:avLst/>
+          </a:prstGeom>
+          <a:noFill/>
+        </p:spPr>
+        <p:txBody>
+          <a:bodyPr wrap="square">
+            <a:spAutoFit/>
+          </a:bodyPr>
+          <a:lstStyle/>
+          <a:p>
+            <a:r>
+              <a:rPr sz="900">
+                <a:solidFill>
+                  <a:srgbClr val="7F8C8D"/>
+                </a:solidFill>
+              </a:rPr>
+              <a:t>この記事は、問い合わせ対応にAI要約や返信下書きを入れる前に、対応品質を測るための小さな集計シートをGoogleスプレッドシートとGASで作る実装メモです。
+AI APIの呼び出しは扱いません。最初に、返信速度だけでなく、解決率、差し戻し、例外対応、FAQ改</a:t>
+            </a:r>
+          </a:p>
+        </p:txBody>
+      </p:sp>
+      <p:sp>
+        <p:nvSpPr>
+          <p:cNvPr id="12" name="TextBox 11"/>
+          <p:cNvSpPr txBox="1"/>
+          <p:nvPr/>
+        </p:nvSpPr>
+        <p:spPr>
+          <a:xfrm>
+            <a:off x="365760" y="3273552"/>
+            <a:ext cx="11430000" cy="472379"/>
+          </a:xfrm>
+          <a:prstGeom prst="rect">
+            <a:avLst/>
+          </a:prstGeom>
+          <a:noFill/>
+        </p:spPr>
+        <p:txBody>
+          <a:bodyPr wrap="square">
+            <a:spAutoFit/>
+          </a:bodyPr>
+          <a:lstStyle/>
+          <a:p>
+            <a:r>
+              <a:rPr sz="1000">
+                <a:solidFill>
+                  <a:srgbClr val="55C500"/>
+                </a:solidFill>
+              </a:rPr>
+              <a:t>▶ </a:t>
+            </a:r>
+            <a:r>
+              <a:rPr sz="1200" b="1">
+                <a:solidFill>
+                  <a:srgbClr val="2C3E50"/>
+                </a:solidFill>
+              </a:rPr>
+              <a:t>RTX 4070 (12GB) で vLLM / SGLang をOOMさせず動かす設定</a:t>
+            </a:r>
+            <a:r>
+              <a:rPr sz="900">
+                <a:solidFill>
+                  <a:srgbClr val="7F8C8D"/>
+                </a:solidFill>
+              </a:rPr>
+              <a:t>  (2026-06-14)</a:t>
+            </a:r>
+          </a:p>
+        </p:txBody>
+      </p:sp>
+      <p:sp>
+        <p:nvSpPr>
+          <p:cNvPr id="13" name="TextBox 12"/>
+          <p:cNvSpPr txBox="1"/>
+          <p:nvPr/>
+        </p:nvSpPr>
+        <p:spPr>
+          <a:xfrm>
+            <a:off x="640080" y="3745931"/>
+            <a:ext cx="11155680" cy="269930"/>
+          </a:xfrm>
+          <a:prstGeom prst="rect">
+            <a:avLst/>
+          </a:prstGeom>
+          <a:noFill/>
+        </p:spPr>
+        <p:txBody>
+          <a:bodyPr wrap="none">
+            <a:spAutoFit/>
+          </a:bodyPr>
+          <a:lstStyle/>
+          <a:p>
+            <a:r>
+              <a:rPr sz="900">
+                <a:solidFill>
+                  <a:srgbClr val="216FD0"/>
+                </a:solidFill>
+                <a:hlinkClick r:id="rId4"/>
+              </a:rPr>
+              <a:t>https://qiita.com/Marron-chan/items/9c7e6102d1eda28e39b9</a:t>
+            </a:r>
+          </a:p>
+        </p:txBody>
+      </p:sp>
+      <p:sp>
+        <p:nvSpPr>
+          <p:cNvPr id="14" name="TextBox 13"/>
+          <p:cNvSpPr txBox="1"/>
+          <p:nvPr/>
+        </p:nvSpPr>
+        <p:spPr>
+          <a:xfrm>
+            <a:off x="640080" y="4015861"/>
+            <a:ext cx="11155680" cy="382402"/>
+          </a:xfrm>
+          <a:prstGeom prst="rect">
+            <a:avLst/>
+          </a:prstGeom>
+          <a:noFill/>
+        </p:spPr>
+        <p:txBody>
+          <a:bodyPr wrap="square">
+            <a:spAutoFit/>
+          </a:bodyPr>
+          <a:lstStyle/>
+          <a:p>
+            <a:r>
+              <a:rPr sz="900">
+                <a:solidFill>
+                  <a:srgbClr val="7F8C8D"/>
+                </a:solidFill>
+              </a:rPr>
+              <a:t>この記事の使い方
+前回（Ollamaが遅い？ 1人なら最速、詰まるのは複数人・RAGから ― vLLM / SGLangを見る判断基準）で「複数人・RAG・低レイテンシで詰まったら vLLM / SGLang を見る」と書きました。
+今回はその続き。12GB</a:t>
+            </a:r>
+          </a:p>
+        </p:txBody>
+      </p:sp>
+      <p:sp>
+        <p:nvSpPr>
+          <p:cNvPr id="15" name="TextBox 14"/>
+          <p:cNvSpPr txBox="1"/>
+          <p:nvPr/>
+        </p:nvSpPr>
+        <p:spPr>
+          <a:xfrm>
+            <a:off x="365760" y="4398264"/>
+            <a:ext cx="11430000" cy="472379"/>
+          </a:xfrm>
+          <a:prstGeom prst="rect">
+            <a:avLst/>
+          </a:prstGeom>
+          <a:noFill/>
+        </p:spPr>
+        <p:txBody>
+          <a:bodyPr wrap="square">
+            <a:spAutoFit/>
+          </a:bodyPr>
+          <a:lstStyle/>
+          <a:p>
+            <a:r>
+              <a:rPr sz="1000">
+                <a:solidFill>
+                  <a:srgbClr val="55C500"/>
+                </a:solidFill>
+              </a:rPr>
+              <a:t>▶ </a:t>
+            </a:r>
+            <a:r>
+              <a:rPr sz="1200" b="1">
+                <a:solidFill>
+                  <a:srgbClr val="2C3E50"/>
+                </a:solidFill>
+              </a:rPr>
+              <a:t>チーム開発でのAPIキー管理、どうしてる？ pydantic-settingsによる型安全・セキュアな一元管理</a:t>
+            </a:r>
+            <a:r>
+              <a:rPr sz="900">
+                <a:solidFill>
+                  <a:srgbClr val="7F8C8D"/>
+                </a:solidFill>
+              </a:rPr>
+              <a:t>  (2026-06-14)</a:t>
+            </a:r>
+          </a:p>
+        </p:txBody>
+      </p:sp>
+      <p:sp>
+        <p:nvSpPr>
+          <p:cNvPr id="16" name="TextBox 15"/>
+          <p:cNvSpPr txBox="1"/>
+          <p:nvPr/>
+        </p:nvSpPr>
+        <p:spPr>
+          <a:xfrm>
+            <a:off x="640080" y="4870643"/>
+            <a:ext cx="11155680" cy="269930"/>
+          </a:xfrm>
+          <a:prstGeom prst="rect">
+            <a:avLst/>
+          </a:prstGeom>
+          <a:noFill/>
+        </p:spPr>
+        <p:txBody>
+          <a:bodyPr wrap="none">
+            <a:spAutoFit/>
+          </a:bodyPr>
+          <a:lstStyle/>
+          <a:p>
+            <a:r>
+              <a:rPr sz="900">
+                <a:solidFill>
+                  <a:srgbClr val="216FD0"/>
+                </a:solidFill>
+                <a:hlinkClick r:id="rId5"/>
+              </a:rPr>
+              <a:t>https://qiita.com/kuririrn/items/1081a10c78fc6bd47fce</a:t>
+            </a:r>
+          </a:p>
+        </p:txBody>
+      </p:sp>
+      <p:sp>
+        <p:nvSpPr>
+          <p:cNvPr id="17" name="TextBox 16"/>
+          <p:cNvSpPr txBox="1"/>
+          <p:nvPr/>
+        </p:nvSpPr>
+        <p:spPr>
+          <a:xfrm>
+            <a:off x="640080" y="5140573"/>
+            <a:ext cx="11155680" cy="382402"/>
+          </a:xfrm>
+          <a:prstGeom prst="rect">
+            <a:avLst/>
+          </a:prstGeom>
+          <a:noFill/>
+        </p:spPr>
+        <p:txBody>
+          <a:bodyPr wrap="square">
+            <a:spAutoFit/>
+          </a:bodyPr>
+          <a:lstStyle/>
+          <a:p>
+            <a:r>
+              <a:rPr sz="900">
+                <a:solidFill>
+                  <a:srgbClr val="7F8C8D"/>
+                </a:solidFill>
+              </a:rPr>
+              <a:t>はじめに
+LLMを活用したエージェントシステムをチームで開発していると、OpenAI・Anthropic・Tavilyなど複数サービスのAPIキーを扱う場面が増えてきます。
+このとき、以下のような課題に直面しました。
+- メンバーごとに異なるAPIキーを</a:t>
+            </a:r>
+          </a:p>
+        </p:txBody>
+      </p:sp>
+      <p:sp>
+        <p:nvSpPr>
+          <p:cNvPr id="18" name="TextBox 17"/>
+          <p:cNvSpPr txBox="1"/>
+          <p:nvPr/>
+        </p:nvSpPr>
+        <p:spPr>
+          <a:xfrm>
+            <a:off x="365760" y="5522976"/>
+            <a:ext cx="11430000" cy="472379"/>
+          </a:xfrm>
+          <a:prstGeom prst="rect">
+            <a:avLst/>
+          </a:prstGeom>
+          <a:noFill/>
+        </p:spPr>
+        <p:txBody>
+          <a:bodyPr wrap="square">
+            <a:spAutoFit/>
+          </a:bodyPr>
+          <a:lstStyle/>
+          <a:p>
+            <a:r>
+              <a:rPr sz="1000">
+                <a:solidFill>
+                  <a:srgbClr val="55C500"/>
+                </a:solidFill>
+              </a:rPr>
+              <a:t>▶ </a:t>
+            </a:r>
+            <a:r>
+              <a:rPr sz="1200" b="1">
+                <a:solidFill>
+                  <a:srgbClr val="2C3E50"/>
+                </a:solidFill>
+              </a:rPr>
+              <a:t>Ollamaが遅い？ 1人なら最速、詰まるのは複数人・RAGから ― vLLM / SGLangを見る判断基準</a:t>
+            </a:r>
+            <a:r>
+              <a:rPr sz="900">
+                <a:solidFill>
+                  <a:srgbClr val="7F8C8D"/>
+                </a:solidFill>
+              </a:rPr>
+              <a:t>  (2026-06-14)</a:t>
+            </a:r>
+          </a:p>
+        </p:txBody>
+      </p:sp>
+      <p:sp>
+        <p:nvSpPr>
+          <p:cNvPr id="19" name="TextBox 18"/>
+          <p:cNvSpPr txBox="1"/>
+          <p:nvPr/>
+        </p:nvSpPr>
+        <p:spPr>
+          <a:xfrm>
+            <a:off x="640080" y="5995355"/>
+            <a:ext cx="11155680" cy="269930"/>
+          </a:xfrm>
+          <a:prstGeom prst="rect">
+            <a:avLst/>
+          </a:prstGeom>
+          <a:noFill/>
+        </p:spPr>
+        <p:txBody>
+          <a:bodyPr wrap="none">
+            <a:spAutoFit/>
+          </a:bodyPr>
+          <a:lstStyle/>
+          <a:p>
+            <a:r>
+              <a:rPr sz="900">
+                <a:solidFill>
+                  <a:srgbClr val="216FD0"/>
+                </a:solidFill>
+                <a:hlinkClick r:id="rId6"/>
+              </a:rPr>
+              <a:t>https://qiita.com/Marron-chan/items/ede825e91c740894c197</a:t>
+            </a:r>
+          </a:p>
+        </p:txBody>
+      </p:sp>
+      <p:sp>
+        <p:nvSpPr>
+          <p:cNvPr id="20" name="TextBox 19"/>
+          <p:cNvSpPr txBox="1"/>
+          <p:nvPr/>
+        </p:nvSpPr>
+        <p:spPr>
+          <a:xfrm>
+            <a:off x="640080" y="6265285"/>
+            <a:ext cx="11155680" cy="382402"/>
+          </a:xfrm>
+          <a:prstGeom prst="rect">
+            <a:avLst/>
+          </a:prstGeom>
+          <a:noFill/>
+        </p:spPr>
+        <p:txBody>
+          <a:bodyPr wrap="square">
+            <a:spAutoFit/>
+          </a:bodyPr>
+          <a:lstStyle/>
+          <a:p>
+            <a:r>
+              <a:rPr sz="900">
+                <a:solidFill>
+                  <a:srgbClr val="7F8C8D"/>
+                </a:solidFill>
+              </a:rPr>
+              <a:t>はじめに
+ローカルLLMを始めるとき、最初に触るのはたいてい Ollama だと思います。
+これだけでモデルが落ちてきて、すぐチャットできる。GPUの設定も、量子化の知識も、サーバの起動オプションもいりません。「とりあえずローカルでLLMを動かす」には</a:t>
             </a:r>
           </a:p>
         </p:txBody>
@@ -3548,7 +4311,7 @@
                             <a:srgbClr val="2C3E50"/>
                           </a:solidFill>
                         </a:rPr>
-                        <a:t>5 件</a:t>
+                        <a:t>7 件</a:t>
                       </a:r>
                     </a:p>
                   </a:txBody>
@@ -3570,7 +4333,7 @@
                             <a:srgbClr val="2C3E50"/>
                           </a:solidFill>
                         </a:rPr>
-                        <a:t>2.3%</a:t>
+                        <a:t>3.3%</a:t>
                       </a:r>
                     </a:p>
                   </a:txBody>
@@ -3616,7 +4379,7 @@
                             <a:srgbClr val="2C3E50"/>
                           </a:solidFill>
                         </a:rPr>
-                        <a:t>77 件</a:t>
+                        <a:t>75 件</a:t>
                       </a:r>
                     </a:p>
                   </a:txBody>
@@ -3638,7 +4401,7 @@
                             <a:srgbClr val="2C3E50"/>
                           </a:solidFill>
                         </a:rPr>
-                        <a:t>36.0%</a:t>
+                        <a:t>34.9%</a:t>
                       </a:r>
                     </a:p>
                   </a:txBody>
@@ -3684,7 +4447,7 @@
                             <a:srgbClr val="2C3E50"/>
                           </a:solidFill>
                         </a:rPr>
-                        <a:t>132 件</a:t>
+                        <a:t>133 件</a:t>
                       </a:r>
                     </a:p>
                   </a:txBody>
@@ -3706,7 +4469,7 @@
                             <a:srgbClr val="2C3E50"/>
                           </a:solidFill>
                         </a:rPr>
-                        <a:t>61.7%</a:t>
+                        <a:t>61.9%</a:t>
                       </a:r>
                     </a:p>
                   </a:txBody>
@@ -3752,7 +4515,7 @@
                             <a:srgbClr val="2C3E50"/>
                           </a:solidFill>
                         </a:rPr>
-                        <a:t>214 件</a:t>
+                        <a:t>215 件</a:t>
                       </a:r>
                     </a:p>
                   </a:txBody>
@@ -3922,7 +4685,7 @@
                   <a:srgbClr val="FFFFFF"/>
                 </a:solidFill>
               </a:rPr>
-              <a:t>HackerNews　記事一覧</a:t>
+              <a:t>HackerNews　記事一覧　(1 / 2)</a:t>
             </a:r>
           </a:p>
         </p:txBody>
@@ -3963,7 +4726,7 @@
                   <a:srgbClr val="2C3E50"/>
                 </a:solidFill>
               </a:rPr>
-              <a:t>Story of How Im Running an Unlimited $6/Month AI Provider on 4x RTX 3090s</a:t>
+              <a:t>New Brunswick woman sues OpenAI, alleging ChatGPT led to daughter's death</a:t>
             </a:r>
             <a:r>
               <a:rPr sz="900">
@@ -4005,7 +4768,7 @@
                 </a:solidFill>
                 <a:hlinkClick r:id="rId2"/>
               </a:rPr>
-              <a:t>https://news.ycombinator.com/item?id=48524387</a:t>
+              <a:t>https://www.cbc.ca/news/canada/new-brunswick/sue-open-ai-suicide-chat-gpt-9.7234630</a:t>
             </a:r>
           </a:p>
         </p:txBody>
@@ -4013,39 +4776,6 @@
       <p:sp>
         <p:nvSpPr>
           <p:cNvPr id="7" name="TextBox 6"/>
-          <p:cNvSpPr txBox="1"/>
-          <p:nvPr/>
-        </p:nvSpPr>
-        <p:spPr>
-          <a:xfrm>
-            <a:off x="640080" y="1766437"/>
-            <a:ext cx="11155680" cy="382402"/>
-          </a:xfrm>
-          <a:prstGeom prst="rect">
-            <a:avLst/>
-          </a:prstGeom>
-          <a:noFill/>
-        </p:spPr>
-        <p:txBody>
-          <a:bodyPr wrap="square">
-            <a:spAutoFit/>
-          </a:bodyPr>
-          <a:lstStyle/>
-          <a:p>
-            <a:r>
-              <a:rPr sz="900">
-                <a:solidFill>
-                  <a:srgbClr val="7F8C8D"/>
-                </a:solidFill>
-              </a:rPr>
-              <a:t>This submission is a tale about how I launched an unlimited LLM provider to about 60 hyped people on the waitlist, then immediatel</a:t>
-            </a:r>
-          </a:p>
-        </p:txBody>
-      </p:sp>
-      <p:sp>
-        <p:nvSpPr>
-          <p:cNvPr id="8" name="TextBox 7"/>
           <p:cNvSpPr txBox="1"/>
           <p:nvPr/>
         </p:nvSpPr>
@@ -4079,7 +4809,7 @@
                   <a:srgbClr val="2C3E50"/>
                 </a:solidFill>
               </a:rPr>
-              <a:t>Hi HN: Loopy agent, meta-loop engineer my Claude Code and codex sessions</a:t>
+              <a:t>Introduction to (Multimodal) LLM-as-a-Judge</a:t>
             </a:r>
             <a:r>
               <a:rPr sz="900">
@@ -4094,7 +4824,7 @@
       </p:sp>
       <p:sp>
         <p:nvSpPr>
-          <p:cNvPr id="9" name="TextBox 8"/>
+          <p:cNvPr id="8" name="TextBox 7"/>
           <p:cNvSpPr txBox="1"/>
           <p:nvPr/>
         </p:nvSpPr>
@@ -4121,14 +4851,14 @@
                 </a:solidFill>
                 <a:hlinkClick r:id="rId3"/>
               </a:rPr>
-              <a:t>https://github.com/secretbuilds/loopy</a:t>
-            </a:r>
-          </a:p>
-        </p:txBody>
-      </p:sp>
-      <p:sp>
-        <p:nvSpPr>
-          <p:cNvPr id="10" name="TextBox 9"/>
+              <a:t>https://yinghonglan.substack.com/p/introduction-to-multimodal-llm-as</a:t>
+            </a:r>
+          </a:p>
+        </p:txBody>
+      </p:sp>
+      <p:sp>
+        <p:nvSpPr>
+          <p:cNvPr id="9" name="TextBox 8"/>
           <p:cNvSpPr txBox="1"/>
           <p:nvPr/>
         </p:nvSpPr>
@@ -4162,7 +4892,7 @@
                   <a:srgbClr val="2C3E50"/>
                 </a:solidFill>
               </a:rPr>
-              <a:t>Making Claude a Chemist</a:t>
+              <a:t>Story of How Im Running an Unlimited $6/Month AI Provider on 4x RTX 3090s</a:t>
             </a:r>
             <a:r>
               <a:rPr sz="900">
@@ -4177,7 +4907,7 @@
       </p:sp>
       <p:sp>
         <p:nvSpPr>
-          <p:cNvPr id="11" name="TextBox 10"/>
+          <p:cNvPr id="10" name="TextBox 9"/>
           <p:cNvSpPr txBox="1"/>
           <p:nvPr/>
         </p:nvSpPr>
@@ -4204,7 +4934,40 @@
                 </a:solidFill>
                 <a:hlinkClick r:id="rId4"/>
               </a:rPr>
-              <a:t>https://www.anthropic.com/research/making-claude-a-chemist</a:t>
+              <a:t>https://news.ycombinator.com/item?id=48524387</a:t>
+            </a:r>
+          </a:p>
+        </p:txBody>
+      </p:sp>
+      <p:sp>
+        <p:nvSpPr>
+          <p:cNvPr id="11" name="TextBox 10"/>
+          <p:cNvSpPr txBox="1"/>
+          <p:nvPr/>
+        </p:nvSpPr>
+        <p:spPr>
+          <a:xfrm>
+            <a:off x="640080" y="4015861"/>
+            <a:ext cx="11155680" cy="382402"/>
+          </a:xfrm>
+          <a:prstGeom prst="rect">
+            <a:avLst/>
+          </a:prstGeom>
+          <a:noFill/>
+        </p:spPr>
+        <p:txBody>
+          <a:bodyPr wrap="square">
+            <a:spAutoFit/>
+          </a:bodyPr>
+          <a:lstStyle/>
+          <a:p>
+            <a:r>
+              <a:rPr sz="900">
+                <a:solidFill>
+                  <a:srgbClr val="7F8C8D"/>
+                </a:solidFill>
+              </a:rPr>
+              <a:t>This submission is a tale about how I launched an unlimited LLM provider to about 60 hyped people on the waitlist, then immediatel</a:t>
             </a:r>
           </a:p>
         </p:txBody>
@@ -4245,7 +5008,7 @@
                   <a:srgbClr val="2C3E50"/>
                 </a:solidFill>
               </a:rPr>
-              <a:t>Show HN: Paca – Lightweight Jira alternative for human-AI collaboration</a:t>
+              <a:t>Hi HN: Loopy agent, meta-loop engineer my Claude Code and codex sessions</a:t>
             </a:r>
             <a:r>
               <a:rPr sz="900">
@@ -4253,7 +5016,7 @@
                   <a:srgbClr val="7F8C8D"/>
                 </a:solidFill>
               </a:rPr>
-              <a:t>  (2026-06-13)</a:t>
+              <a:t>  (2026-06-14)</a:t>
             </a:r>
           </a:p>
         </p:txBody>
@@ -4287,7 +5050,7 @@
                 </a:solidFill>
                 <a:hlinkClick r:id="rId5"/>
               </a:rPr>
-              <a:t>https://github.com/Paca-AI/paca</a:t>
+              <a:t>https://github.com/secretbuilds/loopy</a:t>
             </a:r>
           </a:p>
         </p:txBody>
@@ -4295,39 +5058,6 @@
       <p:sp>
         <p:nvSpPr>
           <p:cNvPr id="14" name="TextBox 13"/>
-          <p:cNvSpPr txBox="1"/>
-          <p:nvPr/>
-        </p:nvSpPr>
-        <p:spPr>
-          <a:xfrm>
-            <a:off x="640080" y="5140573"/>
-            <a:ext cx="11155680" cy="382402"/>
-          </a:xfrm>
-          <a:prstGeom prst="rect">
-            <a:avLst/>
-          </a:prstGeom>
-          <a:noFill/>
-        </p:spPr>
-        <p:txBody>
-          <a:bodyPr wrap="square">
-            <a:spAutoFit/>
-          </a:bodyPr>
-          <a:lstStyle/>
-          <a:p>
-            <a:r>
-              <a:rPr sz="900">
-                <a:solidFill>
-                  <a:srgbClr val="7F8C8D"/>
-                </a:solidFill>
-              </a:rPr>
-              <a:t>I built Paca out of pure passion—a free and lightweight Jira alternative written in Go where humans and AI agents work together as</a:t>
-            </a:r>
-          </a:p>
-        </p:txBody>
-      </p:sp>
-      <p:sp>
-        <p:nvSpPr>
-          <p:cNvPr id="15" name="TextBox 14"/>
           <p:cNvSpPr txBox="1"/>
           <p:nvPr/>
         </p:nvSpPr>
@@ -4361,7 +5091,7 @@
                   <a:srgbClr val="2C3E50"/>
                 </a:solidFill>
               </a:rPr>
-              <a:t>Show HN: I am building a map of people who lived in the Roman Empire</a:t>
+              <a:t>Making Claude a Chemist</a:t>
             </a:r>
             <a:r>
               <a:rPr sz="900">
@@ -4369,14 +5099,14 @@
                   <a:srgbClr val="7F8C8D"/>
                 </a:solidFill>
               </a:rPr>
-              <a:t>  (2026-06-10)</a:t>
-            </a:r>
-          </a:p>
-        </p:txBody>
-      </p:sp>
-      <p:sp>
-        <p:nvSpPr>
-          <p:cNvPr id="16" name="TextBox 15"/>
+              <a:t>  (2026-06-14)</a:t>
+            </a:r>
+          </a:p>
+        </p:txBody>
+      </p:sp>
+      <p:sp>
+        <p:nvSpPr>
+          <p:cNvPr id="15" name="TextBox 14"/>
           <p:cNvSpPr txBox="1"/>
           <p:nvPr/>
         </p:nvSpPr>
@@ -4403,40 +5133,7 @@
                 </a:solidFill>
                 <a:hlinkClick r:id="rId6"/>
               </a:rPr>
-              <a:t>https://new.roman-names.com/</a:t>
-            </a:r>
-          </a:p>
-        </p:txBody>
-      </p:sp>
-      <p:sp>
-        <p:nvSpPr>
-          <p:cNvPr id="17" name="TextBox 16"/>
-          <p:cNvSpPr txBox="1"/>
-          <p:nvPr/>
-        </p:nvSpPr>
-        <p:spPr>
-          <a:xfrm>
-            <a:off x="640080" y="6265285"/>
-            <a:ext cx="11155680" cy="382402"/>
-          </a:xfrm>
-          <a:prstGeom prst="rect">
-            <a:avLst/>
-          </a:prstGeom>
-          <a:noFill/>
-        </p:spPr>
-        <p:txBody>
-          <a:bodyPr wrap="square">
-            <a:spAutoFit/>
-          </a:bodyPr>
-          <a:lstStyle/>
-          <a:p>
-            <a:r>
-              <a:rPr sz="900">
-                <a:solidFill>
-                  <a:srgbClr val="7F8C8D"/>
-                </a:solidFill>
-              </a:rPr>
-              <a:t>Driving home from work one day, I wanted to know how many people we knew the names of who lived during the Roman era. Searching ar</a:t>
+              <a:t>https://www.anthropic.com/research/making-claude-a-chemist</a:t>
             </a:r>
           </a:p>
         </p:txBody>
@@ -4517,7 +5214,7 @@
             <a:avLst/>
           </a:prstGeom>
           <a:solidFill>
-            <a:srgbClr val="3D99F6"/>
+            <a:srgbClr val="FF6600"/>
           </a:solidFill>
           <a:ln>
             <a:noFill/>
@@ -4574,7 +5271,7 @@
                   <a:srgbClr val="FFFFFF"/>
                 </a:solidFill>
               </a:rPr>
-              <a:t>Zenn　記事一覧　(1 / 3)</a:t>
+              <a:t>HackerNews　記事一覧　(2 / 2)</a:t>
             </a:r>
           </a:p>
         </p:txBody>
@@ -4604,7 +5301,7 @@
             <a:r>
               <a:rPr sz="1000">
                 <a:solidFill>
-                  <a:srgbClr val="3D99F6"/>
+                  <a:srgbClr val="FF6600"/>
                 </a:solidFill>
               </a:rPr>
               <a:t>▶ </a:t>
@@ -4615,7 +5312,7 @@
                   <a:srgbClr val="2C3E50"/>
                 </a:solidFill>
               </a:rPr>
-              <a:t>自分のコードを自分でレビューできない — Evaluatorが実際に何を捕まえたか</a:t>
+              <a:t>Show HN: Paca – Lightweight Jira alternative for human-AI collaboration</a:t>
             </a:r>
             <a:r>
               <a:rPr sz="900">
@@ -4657,7 +5354,7 @@
                 </a:solidFill>
                 <a:hlinkClick r:id="rId2"/>
               </a:rPr>
-              <a:t>https://zenn.dev/yamada_ai_dev/articles/claude-code-evaluator-real-catches</a:t>
+              <a:t>https://github.com/Paca-AI/paca</a:t>
             </a:r>
           </a:p>
         </p:txBody>
@@ -4690,10 +5387,7 @@
                   <a:srgbClr val="7F8C8D"/>
                 </a:solidFill>
               </a:rPr>
-              <a:t>自分のコードを自分でレビューできない — Evaluatorが実際に何を捕まえたか
-!
-この記事はClaude Codeのハーネス設計シリーズの一部です。
-Claude Codeを1ヶ月使って気づいた「指示の改善では解決しない問題」 — Evaluator</a:t>
+              <a:t>I built Paca out of pure passion—a free and lightweight Jira alternative written in Go where humans and AI agents work together as</a:t>
             </a:r>
           </a:p>
         </p:txBody>
@@ -4723,7 +5417,7 @@
             <a:r>
               <a:rPr sz="1000">
                 <a:solidFill>
-                  <a:srgbClr val="3D99F6"/>
+                  <a:srgbClr val="FF6600"/>
                 </a:solidFill>
               </a:rPr>
               <a:t>▶ </a:t>
@@ -4734,7 +5428,7 @@
                   <a:srgbClr val="2C3E50"/>
                 </a:solidFill>
               </a:rPr>
-              <a:t>AI Agentは実装前に1コマンド打て</a:t>
+              <a:t>Show HN: I am building a map of people who lived in the Roman Empire</a:t>
             </a:r>
             <a:r>
               <a:rPr sz="900">
@@ -4742,7 +5436,7 @@
                   <a:srgbClr val="7F8C8D"/>
                 </a:solidFill>
               </a:rPr>
-              <a:t>  (2026-06-13)</a:t>
+              <a:t>  (2026-06-10)</a:t>
             </a:r>
           </a:p>
         </p:txBody>
@@ -4776,7 +5470,7 @@
                 </a:solidFill>
                 <a:hlinkClick r:id="rId3"/>
               </a:rPr>
-              <a:t>https://zenn.dev/tadkud/articles/ai-agent-environment-verification-rule</a:t>
+              <a:t>https://new.roman-names.com/</a:t>
             </a:r>
           </a:p>
         </p:txBody>
@@ -4809,365 +5503,7 @@
                   <a:srgbClr val="7F8C8D"/>
                 </a:solidFill>
               </a:rPr>
-              <a:t>はじめに
-AI Agent にコードを書かせるとき、失敗の原因は実装力よりも前提の置き方にあることが多いです。自分の環境でも、2026-05-23 に Docker の実態を見ないまま Oracle ADB 前提で話を進めてしまい、後から「今動いているのは別構</a:t>
-            </a:r>
-          </a:p>
-        </p:txBody>
-      </p:sp>
-      <p:sp>
-        <p:nvSpPr>
-          <p:cNvPr id="11" name="TextBox 10"/>
-          <p:cNvSpPr txBox="1"/>
-          <p:nvPr/>
-        </p:nvSpPr>
-        <p:spPr>
-          <a:xfrm>
-            <a:off x="365760" y="3273552"/>
-            <a:ext cx="11430000" cy="472379"/>
-          </a:xfrm>
-          <a:prstGeom prst="rect">
-            <a:avLst/>
-          </a:prstGeom>
-          <a:noFill/>
-        </p:spPr>
-        <p:txBody>
-          <a:bodyPr wrap="square">
-            <a:spAutoFit/>
-          </a:bodyPr>
-          <a:lstStyle/>
-          <a:p>
-            <a:r>
-              <a:rPr sz="1000">
-                <a:solidFill>
-                  <a:srgbClr val="3D99F6"/>
-                </a:solidFill>
-              </a:rPr>
-              <a:t>▶ </a:t>
-            </a:r>
-            <a:r>
-              <a:rPr sz="1200" b="1">
-                <a:solidFill>
-                  <a:srgbClr val="2C3E50"/>
-                </a:solidFill>
-              </a:rPr>
-              <a:t>AI時代、エンジニアの脳汁駆動開発は実装から設計へ移る</a:t>
-            </a:r>
-            <a:r>
-              <a:rPr sz="900">
-                <a:solidFill>
-                  <a:srgbClr val="7F8C8D"/>
-                </a:solidFill>
-              </a:rPr>
-              <a:t>  (2026-06-13)</a:t>
-            </a:r>
-          </a:p>
-        </p:txBody>
-      </p:sp>
-      <p:sp>
-        <p:nvSpPr>
-          <p:cNvPr id="12" name="TextBox 11"/>
-          <p:cNvSpPr txBox="1"/>
-          <p:nvPr/>
-        </p:nvSpPr>
-        <p:spPr>
-          <a:xfrm>
-            <a:off x="640080" y="3745931"/>
-            <a:ext cx="11155680" cy="269930"/>
-          </a:xfrm>
-          <a:prstGeom prst="rect">
-            <a:avLst/>
-          </a:prstGeom>
-          <a:noFill/>
-        </p:spPr>
-        <p:txBody>
-          <a:bodyPr wrap="none">
-            <a:spAutoFit/>
-          </a:bodyPr>
-          <a:lstStyle/>
-          <a:p>
-            <a:r>
-              <a:rPr sz="900">
-                <a:solidFill>
-                  <a:srgbClr val="216FD0"/>
-                </a:solidFill>
-                <a:hlinkClick r:id="rId4"/>
-              </a:rPr>
-              <a:t>https://zenn.dev/hi_kuma79/articles/81a7ab9178d31f</a:t>
-            </a:r>
-          </a:p>
-        </p:txBody>
-      </p:sp>
-      <p:sp>
-        <p:nvSpPr>
-          <p:cNvPr id="13" name="TextBox 12"/>
-          <p:cNvSpPr txBox="1"/>
-          <p:nvPr/>
-        </p:nvSpPr>
-        <p:spPr>
-          <a:xfrm>
-            <a:off x="640080" y="4015861"/>
-            <a:ext cx="11155680" cy="382402"/>
-          </a:xfrm>
-          <a:prstGeom prst="rect">
-            <a:avLst/>
-          </a:prstGeom>
-          <a:noFill/>
-        </p:spPr>
-        <p:txBody>
-          <a:bodyPr wrap="square">
-            <a:spAutoFit/>
-          </a:bodyPr>
-          <a:lstStyle/>
-          <a:p>
-            <a:r>
-              <a:rPr sz="900">
-                <a:solidFill>
-                  <a:srgbClr val="7F8C8D"/>
-                </a:solidFill>
-              </a:rPr>
-              <a:t>AI時代、エンジニアの脳汁は実装から設計へ移った
-最近、Cursor、Claude Code、GitHub CopilotなどのAI開発ツールを使う機会が増えました。
-使えば使うほど感じることがあります。
-それは、
-エンジニアの脳汁ポイントが実装から設計へ移</a:t>
-            </a:r>
-          </a:p>
-        </p:txBody>
-      </p:sp>
-      <p:sp>
-        <p:nvSpPr>
-          <p:cNvPr id="14" name="TextBox 13"/>
-          <p:cNvSpPr txBox="1"/>
-          <p:nvPr/>
-        </p:nvSpPr>
-        <p:spPr>
-          <a:xfrm>
-            <a:off x="365760" y="4398264"/>
-            <a:ext cx="11430000" cy="472379"/>
-          </a:xfrm>
-          <a:prstGeom prst="rect">
-            <a:avLst/>
-          </a:prstGeom>
-          <a:noFill/>
-        </p:spPr>
-        <p:txBody>
-          <a:bodyPr wrap="square">
-            <a:spAutoFit/>
-          </a:bodyPr>
-          <a:lstStyle/>
-          <a:p>
-            <a:r>
-              <a:rPr sz="1000">
-                <a:solidFill>
-                  <a:srgbClr val="3D99F6"/>
-                </a:solidFill>
-              </a:rPr>
-              <a:t>▶ </a:t>
-            </a:r>
-            <a:r>
-              <a:rPr sz="1200" b="1">
-                <a:solidFill>
-                  <a:srgbClr val="2C3E50"/>
-                </a:solidFill>
-              </a:rPr>
-              <a:t>日本語RAGに向く中国製オープンソースパーサーはどれか — クロスオーバーだった。BM25ならDeepDoc、denseならMinerU</a:t>
-            </a:r>
-            <a:r>
-              <a:rPr sz="900">
-                <a:solidFill>
-                  <a:srgbClr val="7F8C8D"/>
-                </a:solidFill>
-              </a:rPr>
-              <a:t>  (2026-06-13)</a:t>
-            </a:r>
-          </a:p>
-        </p:txBody>
-      </p:sp>
-      <p:sp>
-        <p:nvSpPr>
-          <p:cNvPr id="15" name="TextBox 14"/>
-          <p:cNvSpPr txBox="1"/>
-          <p:nvPr/>
-        </p:nvSpPr>
-        <p:spPr>
-          <a:xfrm>
-            <a:off x="640080" y="4870643"/>
-            <a:ext cx="11155680" cy="269930"/>
-          </a:xfrm>
-          <a:prstGeom prst="rect">
-            <a:avLst/>
-          </a:prstGeom>
-          <a:noFill/>
-        </p:spPr>
-        <p:txBody>
-          <a:bodyPr wrap="none">
-            <a:spAutoFit/>
-          </a:bodyPr>
-          <a:lstStyle/>
-          <a:p>
-            <a:r>
-              <a:rPr sz="900">
-                <a:solidFill>
-                  <a:srgbClr val="216FD0"/>
-                </a:solidFill>
-                <a:hlinkClick r:id="rId5"/>
-              </a:rPr>
-              <a:t>https://zenn.dev/elvisyao/articles/930a510164a798</a:t>
-            </a:r>
-          </a:p>
-        </p:txBody>
-      </p:sp>
-      <p:sp>
-        <p:nvSpPr>
-          <p:cNvPr id="16" name="TextBox 15"/>
-          <p:cNvSpPr txBox="1"/>
-          <p:nvPr/>
-        </p:nvSpPr>
-        <p:spPr>
-          <a:xfrm>
-            <a:off x="640080" y="5140573"/>
-            <a:ext cx="11155680" cy="382402"/>
-          </a:xfrm>
-          <a:prstGeom prst="rect">
-            <a:avLst/>
-          </a:prstGeom>
-          <a:noFill/>
-        </p:spPr>
-        <p:txBody>
-          <a:bodyPr wrap="square">
-            <a:spAutoFit/>
-          </a:bodyPr>
-          <a:lstStyle/>
-          <a:p>
-            <a:r>
-              <a:rPr sz="900">
-                <a:solidFill>
-                  <a:srgbClr val="7F8C8D"/>
-                </a:solidFill>
-              </a:rPr>
-              <a:t>!
-中国オープンソースのドキュメントパースを日本語文書で計測するシリーズの最終回です。
-英語版（canonical）: https://dev.to/elvisyao007/which-chinese-open-source-parser-is-better-</a:t>
-            </a:r>
-          </a:p>
-        </p:txBody>
-      </p:sp>
-      <p:sp>
-        <p:nvSpPr>
-          <p:cNvPr id="17" name="TextBox 16"/>
-          <p:cNvSpPr txBox="1"/>
-          <p:nvPr/>
-        </p:nvSpPr>
-        <p:spPr>
-          <a:xfrm>
-            <a:off x="365760" y="5522976"/>
-            <a:ext cx="11430000" cy="472379"/>
-          </a:xfrm>
-          <a:prstGeom prst="rect">
-            <a:avLst/>
-          </a:prstGeom>
-          <a:noFill/>
-        </p:spPr>
-        <p:txBody>
-          <a:bodyPr wrap="square">
-            <a:spAutoFit/>
-          </a:bodyPr>
-          <a:lstStyle/>
-          <a:p>
-            <a:r>
-              <a:rPr sz="1000">
-                <a:solidFill>
-                  <a:srgbClr val="3D99F6"/>
-                </a:solidFill>
-              </a:rPr>
-              <a:t>▶ </a:t>
-            </a:r>
-            <a:r>
-              <a:rPr sz="1200" b="1">
-                <a:solidFill>
-                  <a:srgbClr val="2C3E50"/>
-                </a:solidFill>
-              </a:rPr>
-              <a:t>AIエージェント時代の品質保証 ― 監査駆動フィードバック開発という考え方</a:t>
-            </a:r>
-            <a:r>
-              <a:rPr sz="900">
-                <a:solidFill>
-                  <a:srgbClr val="7F8C8D"/>
-                </a:solidFill>
-              </a:rPr>
-              <a:t>  (2026-06-13)</a:t>
-            </a:r>
-          </a:p>
-        </p:txBody>
-      </p:sp>
-      <p:sp>
-        <p:nvSpPr>
-          <p:cNvPr id="18" name="TextBox 17"/>
-          <p:cNvSpPr txBox="1"/>
-          <p:nvPr/>
-        </p:nvSpPr>
-        <p:spPr>
-          <a:xfrm>
-            <a:off x="640080" y="5995355"/>
-            <a:ext cx="11155680" cy="269930"/>
-          </a:xfrm>
-          <a:prstGeom prst="rect">
-            <a:avLst/>
-          </a:prstGeom>
-          <a:noFill/>
-        </p:spPr>
-        <p:txBody>
-          <a:bodyPr wrap="none">
-            <a:spAutoFit/>
-          </a:bodyPr>
-          <a:lstStyle/>
-          <a:p>
-            <a:r>
-              <a:rPr sz="900">
-                <a:solidFill>
-                  <a:srgbClr val="216FD0"/>
-                </a:solidFill>
-                <a:hlinkClick r:id="rId6"/>
-              </a:rPr>
-              <a:t>https://zenn.dev/ichikawa_y/articles/audit-driven-feedback-development</a:t>
-            </a:r>
-          </a:p>
-        </p:txBody>
-      </p:sp>
-      <p:sp>
-        <p:nvSpPr>
-          <p:cNvPr id="19" name="TextBox 18"/>
-          <p:cNvSpPr txBox="1"/>
-          <p:nvPr/>
-        </p:nvSpPr>
-        <p:spPr>
-          <a:xfrm>
-            <a:off x="640080" y="6265285"/>
-            <a:ext cx="11155680" cy="382402"/>
-          </a:xfrm>
-          <a:prstGeom prst="rect">
-            <a:avLst/>
-          </a:prstGeom>
-          <a:noFill/>
-        </p:spPr>
-        <p:txBody>
-          <a:bodyPr wrap="square">
-            <a:spAutoFit/>
-          </a:bodyPr>
-          <a:lstStyle/>
-          <a:p>
-            <a:r>
-              <a:rPr sz="900">
-                <a:solidFill>
-                  <a:srgbClr val="7F8C8D"/>
-                </a:solidFill>
-              </a:rPr>
-              <a:t>はじめに ― AI開発で本当に怖いのは「少数の整合性崩壊」
-AI エージェントに 100 件のタスクを任せたとします。おそらく 95 件は正しく実装されます。問題は残りの 5 件です。
-機能は動くが、通知だけ配線されていない
-レスポンスは正しいが、Open</a:t>
+              <a:t>Driving home from work one day, I wanted to know how many people we knew the names of who lived during the Roman era. Searching ar</a:t>
             </a:r>
           </a:p>
         </p:txBody>
@@ -5305,7 +5641,7 @@
                   <a:srgbClr val="FFFFFF"/>
                 </a:solidFill>
               </a:rPr>
-              <a:t>Zenn　記事一覧　(2 / 3)</a:t>
+              <a:t>Zenn　記事一覧　(1 / 3)</a:t>
             </a:r>
           </a:p>
         </p:txBody>
@@ -5346,7 +5682,7 @@
                   <a:srgbClr val="2C3E50"/>
                 </a:solidFill>
               </a:rPr>
-              <a:t>AIの返事を「必ずJSON」にする——Claude構造化出力入門</a:t>
+              <a:t>センスの根幹はLLMではなくRAGだった</a:t>
             </a:r>
             <a:r>
               <a:rPr sz="900">
@@ -5354,7 +5690,7 @@
                   <a:srgbClr val="7F8C8D"/>
                 </a:solidFill>
               </a:rPr>
-              <a:t>  (2026-06-13)</a:t>
+              <a:t>  (2026-06-14)</a:t>
             </a:r>
           </a:p>
         </p:txBody>
@@ -5388,7 +5724,7 @@
                 </a:solidFill>
                 <a:hlinkClick r:id="rId2"/>
               </a:rPr>
-              <a:t>https://zenn.dev/shun_producer/articles/claude-structured-outputs-beginner</a:t>
+              <a:t>https://zenn.dev/mofuteq/articles/4b036078c7512d</a:t>
             </a:r>
           </a:p>
         </p:txBody>
@@ -5421,10 +5757,14 @@
                   <a:srgbClr val="7F8C8D"/>
                 </a:solidFill>
               </a:rPr>
-              <a:t>はじめに——「AIの返事、プログラムで使えない問題」
-AIに「この文章から名前とメールアドレスを抜き出して、JSONで返して」とお願いしたことはないだろうか。
-だいたいは、ちゃんと返してくれる。でも、たまに裏切られる。
-JSONの前に「はい、抽出しました！」</a:t>
+              <a:t>LLMにセンスを任せない
+ファッションの相談を、AIにやらせようとすると、つい「センスのあるAI」を作りたくなります。
+この服は良い。
+これは微妙。
+この組み合わせがおすすめ。
+これが今っぽい。
+そういう判定をしてくれると、アプリとしては分かりやすい。
+ど典型</a:t>
             </a:r>
           </a:p>
         </p:txBody>
@@ -5465,7 +5805,7 @@
                   <a:srgbClr val="2C3E50"/>
                 </a:solidFill>
               </a:rPr>
-              <a:t>GitHub Copilot 難民 ～ Cluade Code ～ Google AI Studio ～ そして Codex へ</a:t>
+              <a:t>自分のコードを自分でレビューできない — Evaluatorが実際に何を捕まえたか</a:t>
             </a:r>
             <a:r>
               <a:rPr sz="900">
@@ -5507,7 +5847,7 @@
                 </a:solidFill>
                 <a:hlinkClick r:id="rId3"/>
               </a:rPr>
-              <a:t>https://zenn.dev/ssknaoya/articles/d9becba1164230</a:t>
+              <a:t>https://zenn.dev/yamada_ai_dev/articles/claude-code-evaluator-real-catches</a:t>
             </a:r>
           </a:p>
         </p:txBody>
@@ -5540,11 +5880,10 @@
                   <a:srgbClr val="7F8C8D"/>
                 </a:solidFill>
               </a:rPr>
-              <a:t>概要
-GitHub Copilot Pro がグダっているのでその他のAIサービスを色々試してみたという話。
- 結論
-VS Code + Copilot のセミバイブコーディングな使用感に近いのは ChatGPT Plus で使用する Codex
-Clau</a:t>
+              <a:t>自分のコードを自分でレビューできない — Evaluatorが実際に何を捕まえたか
+!
+この記事はClaude Codeのハーネス設計シリーズの一部です。
+Claude Codeを1ヶ月使って気づいた「指示の改善では解決しない問題」 — Evaluator</a:t>
             </a:r>
           </a:p>
         </p:txBody>
@@ -5585,7 +5924,7 @@
                   <a:srgbClr val="2C3E50"/>
                 </a:solidFill>
               </a:rPr>
-              <a:t>Gradient Surgery for Multi-Task Learning</a:t>
+              <a:t>AI Agentは実装前に1コマンド打て</a:t>
             </a:r>
             <a:r>
               <a:rPr sz="900">
@@ -5627,7 +5966,7 @@
                 </a:solidFill>
                 <a:hlinkClick r:id="rId4"/>
               </a:rPr>
-              <a:t>https://zenn.dev/oyatomo/articles/6da8bc0d7900cd</a:t>
+              <a:t>https://zenn.dev/tadkud/articles/ai-agent-environment-verification-rule</a:t>
             </a:r>
           </a:p>
         </p:txBody>
@@ -5660,10 +5999,8 @@
                   <a:srgbClr val="7F8C8D"/>
                 </a:solidFill>
               </a:rPr>
-              <a:t>ご挨拶
-皆さんこんにちは、一関高専 村上研究室 小山田です。
-この記事は、研究室内での論文輪読会用の資料です。
-今回紹介する内容は、PCGrad (Project Conflicting Gradients) という勾配衝突を防止する手法の論文とその実装方法に</a:t>
+              <a:t>はじめに
+AI Agent にコードを書かせるとき、失敗の原因は実装力よりも前提の置き方にあることが多いです。自分の環境でも、2026-05-23 に Docker の実態を見ないまま Oracle ADB 前提で話を進めてしまい、後から「今動いているのは別構</a:t>
             </a:r>
           </a:p>
         </p:txBody>
@@ -5704,7 +6041,7 @@
                   <a:srgbClr val="2C3E50"/>
                 </a:solidFill>
               </a:rPr>
-              <a:t>CLAUDE.mdに書いたのに守られない——その正体は「渡す場所」の設計だった（Zenn Book Vol.4「仕組みを渡すまで」）</a:t>
+              <a:t>AI時代、エンジニアの脳汁駆動開発は実装から設計へ移る</a:t>
             </a:r>
             <a:r>
               <a:rPr sz="900">
@@ -5746,7 +6083,7 @@
                 </a:solidFill>
                 <a:hlinkClick r:id="rId5"/>
               </a:rPr>
-              <a:t>https://zenn.dev/tottoko_hamu/articles/2026-06-11-173500</a:t>
+              <a:t>https://zenn.dev/hi_kuma79/articles/81a7ab9178d31f</a:t>
             </a:r>
           </a:p>
         </p:txBody>
@@ -5779,7 +6116,11 @@
                   <a:srgbClr val="7F8C8D"/>
                 </a:solidFill>
               </a:rPr>
-              <a:t>この記事の概要（2026年6月）: Claude Codeに「仕組み」を渡すための部品論をまとめたZenn Book Vol.4「コードを書けない私がClaude Codeに『仕組み』を渡すまで」を紹介する。「CLAUDE.mdに書いたのに守られない」「サブエ</a:t>
+              <a:t>AI時代、エンジニアの脳汁は実装から設計へ移った
+最近、Cursor、Claude Code、GitHub CopilotなどのAI開発ツールを使う機会が増えました。
+使えば使うほど感じることがあります。
+それは、
+エンジニアの脳汁ポイントが実装から設計へ移</a:t>
             </a:r>
           </a:p>
         </p:txBody>
@@ -5820,7 +6161,7 @@
                   <a:srgbClr val="2C3E50"/>
                 </a:solidFill>
               </a:rPr>
-              <a:t>LLMは長文を本当に読めているのか？「Lost in the Middle」から考えるRAG設計</a:t>
+              <a:t>日本語RAGに向く中国製オープンソースパーサーはどれか — クロスオーバーだった。BM25ならDeepDoc、denseならMinerU</a:t>
             </a:r>
             <a:r>
               <a:rPr sz="900">
@@ -5862,7 +6203,7 @@
                 </a:solidFill>
                 <a:hlinkClick r:id="rId6"/>
               </a:rPr>
-              <a:t>https://zenn.dev/japan/articles/73ad921caeb0bd</a:t>
+              <a:t>https://zenn.dev/elvisyao/articles/930a510164a798</a:t>
             </a:r>
           </a:p>
         </p:txBody>
@@ -5895,10 +6236,9 @@
                   <a:srgbClr val="7F8C8D"/>
                 </a:solidFill>
               </a:rPr>
-              <a:t>LLMアプリケーションを作っていると、次のような発想になりがちです。
-コンテキストウィンドウが大きいモデルを使えば、とりあえず大量のドキュメントを詰め込めばよいのでは？
-しかし、実際にはそう単純ではありません。
-LLMには、長い入力の中に含まれる情報を均等</a:t>
+              <a:t>!
+中国オープンソースのドキュメントパースを日本語文書で計測するシリーズの最終回です。
+英語版（canonical）: https://dev.to/elvisyao007/which-chinese-open-source-parser-is-better-</a:t>
             </a:r>
           </a:p>
         </p:txBody>
@@ -6036,7 +6376,7 @@
                   <a:srgbClr val="FFFFFF"/>
                 </a:solidFill>
               </a:rPr>
-              <a:t>Zenn　記事一覧　(3 / 3)</a:t>
+              <a:t>Zenn　記事一覧　(2 / 3)</a:t>
             </a:r>
           </a:p>
         </p:txBody>
@@ -6044,40 +6384,6 @@
       <p:sp>
         <p:nvSpPr>
           <p:cNvPr id="5" name="TextBox 4"/>
-          <p:cNvSpPr txBox="1"/>
-          <p:nvPr/>
-        </p:nvSpPr>
-        <p:spPr>
-          <a:xfrm>
-            <a:off x="365760" y="6510528"/>
-            <a:ext cx="11430000" cy="320040"/>
-          </a:xfrm>
-          <a:prstGeom prst="rect">
-            <a:avLst/>
-          </a:prstGeom>
-          <a:noFill/>
-        </p:spPr>
-        <p:txBody>
-          <a:bodyPr wrap="square">
-            <a:spAutoFit/>
-          </a:bodyPr>
-          <a:lstStyle/>
-          <a:p>
-            <a:pPr algn="l"/>
-            <a:r>
-              <a:rPr sz="900" b="0">
-                <a:solidFill>
-                  <a:srgbClr val="7F8C8D"/>
-                </a:solidFill>
-              </a:rPr>
-              <a:t>※ 他 62 件は JSON アーカイブを参照</a:t>
-            </a:r>
-          </a:p>
-        </p:txBody>
-      </p:sp>
-      <p:sp>
-        <p:nvSpPr>
-          <p:cNvPr id="6" name="TextBox 5"/>
           <p:cNvSpPr txBox="1"/>
           <p:nvPr/>
         </p:nvSpPr>
@@ -6111,7 +6417,7 @@
                   <a:srgbClr val="2C3E50"/>
                 </a:solidFill>
               </a:rPr>
-              <a:t>Scale-to-Zero は弱点じゃない——S3 Vectors × OpenSearch Serverless の二段検索 RAG</a:t>
+              <a:t>AIエージェント時代の品質保証 ― 監査駆動フィードバック開発という考え方</a:t>
             </a:r>
             <a:r>
               <a:rPr sz="900">
@@ -6126,7 +6432,7 @@
       </p:sp>
       <p:sp>
         <p:nvSpPr>
-          <p:cNvPr id="7" name="TextBox 6"/>
+          <p:cNvPr id="6" name="TextBox 5"/>
           <p:cNvSpPr txBox="1"/>
           <p:nvPr/>
         </p:nvSpPr>
@@ -6153,14 +6459,14 @@
                 </a:solidFill>
                 <a:hlinkClick r:id="rId2"/>
               </a:rPr>
-              <a:t>https://zenn.dev/honey_aws/articles/scale-to-zero-dual-vector-rag</a:t>
-            </a:r>
-          </a:p>
-        </p:txBody>
-      </p:sp>
-      <p:sp>
-        <p:nvSpPr>
-          <p:cNvPr id="8" name="TextBox 7"/>
+              <a:t>https://zenn.dev/ichikawa_y/articles/audit-driven-feedback-development</a:t>
+            </a:r>
+          </a:p>
+        </p:txBody>
+      </p:sp>
+      <p:sp>
+        <p:nvSpPr>
+          <p:cNvPr id="7" name="TextBox 6"/>
           <p:cNvSpPr txBox="1"/>
           <p:nvPr/>
         </p:nvSpPr>
@@ -6186,15 +6492,17 @@
                   <a:srgbClr val="7F8C8D"/>
                 </a:solidFill>
               </a:rPr>
-              <a:t>はじめに
-サーバーレスの「scale-to-zero」（使われていない間はリソースが 0 までスケールして課金が止まる）は、コストの面ではうれしい仕組みです。一方で コールドスタート——アイドル後の初回リクエストで暖機に十数秒かかる——という弱点とセットで語ら</a:t>
-            </a:r>
-          </a:p>
-        </p:txBody>
-      </p:sp>
-      <p:sp>
-        <p:nvSpPr>
-          <p:cNvPr id="9" name="TextBox 8"/>
+              <a:t>はじめに ― AI開発で本当に怖いのは「少数の整合性崩壊」
+AI エージェントに 100 件のタスクを任せたとします。おそらく 95 件は正しく実装されます。問題は残りの 5 件です。
+機能は動くが、通知だけ配線されていない
+レスポンスは正しいが、Open</a:t>
+            </a:r>
+          </a:p>
+        </p:txBody>
+      </p:sp>
+      <p:sp>
+        <p:nvSpPr>
+          <p:cNvPr id="8" name="TextBox 7"/>
           <p:cNvSpPr txBox="1"/>
           <p:nvPr/>
         </p:nvSpPr>
@@ -6228,7 +6536,7 @@
                   <a:srgbClr val="2C3E50"/>
                 </a:solidFill>
               </a:rPr>
-              <a:t>LLMOps学習でBedrock + Claudeを動かしてみた</a:t>
+              <a:t>AIの返事を「必ずJSON」にする——Claude構造化出力入門</a:t>
             </a:r>
             <a:r>
               <a:rPr sz="900">
@@ -6243,7 +6551,7 @@
       </p:sp>
       <p:sp>
         <p:nvSpPr>
-          <p:cNvPr id="10" name="TextBox 9"/>
+          <p:cNvPr id="9" name="TextBox 8"/>
           <p:cNvSpPr txBox="1"/>
           <p:nvPr/>
         </p:nvSpPr>
@@ -6270,14 +6578,14 @@
                 </a:solidFill>
                 <a:hlinkClick r:id="rId3"/>
               </a:rPr>
-              <a:t>https://zenn.dev/yukika/articles/20260613_bedrock_claude_first_step</a:t>
-            </a:r>
-          </a:p>
-        </p:txBody>
-      </p:sp>
-      <p:sp>
-        <p:nvSpPr>
-          <p:cNvPr id="11" name="TextBox 10"/>
+              <a:t>https://zenn.dev/shun_producer/articles/claude-structured-outputs-beginner</a:t>
+            </a:r>
+          </a:p>
+        </p:txBody>
+      </p:sp>
+      <p:sp>
+        <p:nvSpPr>
+          <p:cNvPr id="10" name="TextBox 9"/>
           <p:cNvSpPr txBox="1"/>
           <p:nvPr/>
         </p:nvSpPr>
@@ -6303,18 +6611,17 @@
                   <a:srgbClr val="7F8C8D"/>
                 </a:solidFill>
               </a:rPr>
-              <a:t>はじめに
-こんにちは。
-最近、LLMOpsに興味を持ち始めました。
-Claude Codeはよく触っているのですが、LLMをプログラムから呼び出して使う、みたいなことはやったことがありませんでした。
-Bedrockもまともに触ったことがなかったので、併せて試し</a:t>
-            </a:r>
-          </a:p>
-        </p:txBody>
-      </p:sp>
-      <p:sp>
-        <p:nvSpPr>
-          <p:cNvPr id="12" name="TextBox 11"/>
+              <a:t>はじめに——「AIの返事、プログラムで使えない問題」
+AIに「この文章から名前とメールアドレスを抜き出して、JSONで返して」とお願いしたことはないだろうか。
+だいたいは、ちゃんと返してくれる。でも、たまに裏切られる。
+JSONの前に「はい、抽出しました！」</a:t>
+            </a:r>
+          </a:p>
+        </p:txBody>
+      </p:sp>
+      <p:sp>
+        <p:nvSpPr>
+          <p:cNvPr id="11" name="TextBox 10"/>
           <p:cNvSpPr txBox="1"/>
           <p:nvPr/>
         </p:nvSpPr>
@@ -6348,7 +6655,7 @@
                   <a:srgbClr val="2C3E50"/>
                 </a:solidFill>
               </a:rPr>
-              <a:t>社内ガイドラインが効かない、情報漏洩は安易な個人AI利用からはじまる</a:t>
+              <a:t>GitHub Copilot 難民 ～ Cluade Code ～ Google AI Studio ～ そして Codex へ</a:t>
             </a:r>
             <a:r>
               <a:rPr sz="900">
@@ -6363,7 +6670,7 @@
       </p:sp>
       <p:sp>
         <p:nvSpPr>
-          <p:cNvPr id="13" name="TextBox 12"/>
+          <p:cNvPr id="12" name="TextBox 11"/>
           <p:cNvSpPr txBox="1"/>
           <p:nvPr/>
         </p:nvSpPr>
@@ -6390,14 +6697,14 @@
                 </a:solidFill>
                 <a:hlinkClick r:id="rId4"/>
               </a:rPr>
-              <a:t>https://zenn.dev/syoshida07/articles/baa36522c872e6</a:t>
-            </a:r>
-          </a:p>
-        </p:txBody>
-      </p:sp>
-      <p:sp>
-        <p:nvSpPr>
-          <p:cNvPr id="14" name="TextBox 13"/>
+              <a:t>https://zenn.dev/ssknaoya/articles/d9becba1164230</a:t>
+            </a:r>
+          </a:p>
+        </p:txBody>
+      </p:sp>
+      <p:sp>
+        <p:nvSpPr>
+          <p:cNvPr id="13" name="TextBox 12"/>
           <p:cNvSpPr txBox="1"/>
           <p:nvPr/>
         </p:nvSpPr>
@@ -6423,15 +6730,18 @@
                   <a:srgbClr val="7F8C8D"/>
                 </a:solidFill>
               </a:rPr>
-              <a:t>2025〜2026年の政府・公的機関の分析では、企業の生成AIガバナンスは「整備は進んだが、遵守は追いついていない」という評価が共通している。
-特にデジタル庁(2025)と経産省AI事業者ガイドライン(2026)は、ガイドラインは作っただけでは意味がないと明確</a:t>
-            </a:r>
-          </a:p>
-        </p:txBody>
-      </p:sp>
-      <p:sp>
-        <p:nvSpPr>
-          <p:cNvPr id="15" name="TextBox 14"/>
+              <a:t>概要
+GitHub Copilot Pro がグダっているのでその他のAIサービスを色々試してみたという話。
+ 結論
+VS Code + Copilot のセミバイブコーディングな使用感に近いのは ChatGPT Plus で使用する Codex
+Clau</a:t>
+            </a:r>
+          </a:p>
+        </p:txBody>
+      </p:sp>
+      <p:sp>
+        <p:nvSpPr>
+          <p:cNvPr id="14" name="TextBox 13"/>
           <p:cNvSpPr txBox="1"/>
           <p:nvPr/>
         </p:nvSpPr>
@@ -6465,7 +6775,7 @@
                   <a:srgbClr val="2C3E50"/>
                 </a:solidFill>
               </a:rPr>
-              <a:t>多層プロンプトスキーマ（Hierarchical Prompt Schema）</a:t>
+              <a:t>Gradient Surgery for Multi-Task Learning</a:t>
             </a:r>
             <a:r>
               <a:rPr sz="900">
@@ -6480,7 +6790,7 @@
       </p:sp>
       <p:sp>
         <p:nvSpPr>
-          <p:cNvPr id="16" name="TextBox 15"/>
+          <p:cNvPr id="15" name="TextBox 14"/>
           <p:cNvSpPr txBox="1"/>
           <p:nvPr/>
         </p:nvSpPr>
@@ -6507,14 +6817,14 @@
                 </a:solidFill>
                 <a:hlinkClick r:id="rId5"/>
               </a:rPr>
-              <a:t>https://zenn.dev/yoshi_katakura/articles/3b1952f0096a64</a:t>
-            </a:r>
-          </a:p>
-        </p:txBody>
-      </p:sp>
-      <p:sp>
-        <p:nvSpPr>
-          <p:cNvPr id="17" name="TextBox 16"/>
+              <a:t>https://zenn.dev/oyatomo/articles/6da8bc0d7900cd</a:t>
+            </a:r>
+          </a:p>
+        </p:txBody>
+      </p:sp>
+      <p:sp>
+        <p:nvSpPr>
+          <p:cNvPr id="16" name="TextBox 15"/>
           <p:cNvSpPr txBox="1"/>
           <p:nvPr/>
         </p:nvSpPr>
@@ -6540,20 +6850,17 @@
                   <a:srgbClr val="7F8C8D"/>
                 </a:solidFill>
               </a:rPr>
-              <a:t>LLMのルール矛盾を自動検出・Mermaid構造化で解消する設計
-LLMのシステムプロンプトは「自然言語で書かれたルール集」です。
-しかし自然言語はコンパイルエラーを出しません。
-「日本語で回答する」
-「英語で話すアインシュタインAI」
-「必ず指名する」
-「最</a:t>
-            </a:r>
-          </a:p>
-        </p:txBody>
-      </p:sp>
-      <p:sp>
-        <p:nvSpPr>
-          <p:cNvPr id="18" name="TextBox 17"/>
+              <a:t>ご挨拶
+皆さんこんにちは、一関高専 村上研究室 小山田です。
+この記事は、研究室内での論文輪読会用の資料です。
+今回紹介する内容は、PCGrad (Project Conflicting Gradients) という勾配衝突を防止する手法の論文とその実装方法に</a:t>
+            </a:r>
+          </a:p>
+        </p:txBody>
+      </p:sp>
+      <p:sp>
+        <p:nvSpPr>
+          <p:cNvPr id="17" name="TextBox 16"/>
           <p:cNvSpPr txBox="1"/>
           <p:nvPr/>
         </p:nvSpPr>
@@ -6587,7 +6894,7 @@
                   <a:srgbClr val="2C3E50"/>
                 </a:solidFill>
               </a:rPr>
-              <a:t>構造化パースはBM25よりdense検索を助ける — 日本語文書で計測、差は2倍に広がった</a:t>
+              <a:t>CLAUDE.mdに書いたのに守られない——その正体は「渡す場所」の設計だった（Zenn Book Vol.4「仕組みを渡すまで」）</a:t>
             </a:r>
             <a:r>
               <a:rPr sz="900">
@@ -6602,7 +6909,7 @@
       </p:sp>
       <p:sp>
         <p:nvSpPr>
-          <p:cNvPr id="19" name="TextBox 18"/>
+          <p:cNvPr id="18" name="TextBox 17"/>
           <p:cNvSpPr txBox="1"/>
           <p:nvPr/>
         </p:nvSpPr>
@@ -6629,14 +6936,14 @@
                 </a:solidFill>
                 <a:hlinkClick r:id="rId6"/>
               </a:rPr>
-              <a:t>https://zenn.dev/elvisyao/articles/ddb59295fc5b31</a:t>
-            </a:r>
-          </a:p>
-        </p:txBody>
-      </p:sp>
-      <p:sp>
-        <p:nvSpPr>
-          <p:cNvPr id="20" name="TextBox 19"/>
+              <a:t>https://zenn.dev/tottoko_hamu/articles/2026-06-11-173500</a:t>
+            </a:r>
+          </a:p>
+        </p:txBody>
+      </p:sp>
+      <p:sp>
+        <p:nvSpPr>
+          <p:cNvPr id="19" name="TextBox 18"/>
           <p:cNvSpPr txBox="1"/>
           <p:nvPr/>
         </p:nvSpPr>
@@ -6662,9 +6969,7 @@
                   <a:srgbClr val="7F8C8D"/>
                 </a:solidFill>
               </a:rPr>
-              <a:t>!
-中国オープンソースのパース（RAGFlowのDeepDoc）を日本語文書で計測するシリーズのPhase 3です。前回の記事で明示した2つの限界を収紧します。
-英語版（canonical）: https://dev.to/elvisyao007/REPLAC</a:t>
+              <a:t>この記事の概要（2026年6月）: Claude Codeに「仕組み」を渡すための部品論をまとめたZenn Book Vol.4「コードを書けない私がClaude Codeに『仕組み』を渡すまで」を紹介する。「CLAUDE.mdに書いたのに守られない」「サブエ</a:t>
             </a:r>
           </a:p>
         </p:txBody>
@@ -6745,7 +7050,7 @@
             <a:avLst/>
           </a:prstGeom>
           <a:solidFill>
-            <a:srgbClr val="55C500"/>
+            <a:srgbClr val="3D99F6"/>
           </a:solidFill>
           <a:ln>
             <a:noFill/>
@@ -6802,7 +7107,7 @@
                   <a:srgbClr val="FFFFFF"/>
                 </a:solidFill>
               </a:rPr>
-              <a:t>Qiita　記事一覧　(1 / 3)</a:t>
+              <a:t>Zenn　記事一覧　(3 / 3)</a:t>
             </a:r>
           </a:p>
         </p:txBody>
@@ -6810,6 +7115,40 @@
       <p:sp>
         <p:nvSpPr>
           <p:cNvPr id="5" name="TextBox 4"/>
+          <p:cNvSpPr txBox="1"/>
+          <p:nvPr/>
+        </p:nvSpPr>
+        <p:spPr>
+          <a:xfrm>
+            <a:off x="365760" y="6510528"/>
+            <a:ext cx="11430000" cy="320040"/>
+          </a:xfrm>
+          <a:prstGeom prst="rect">
+            <a:avLst/>
+          </a:prstGeom>
+          <a:noFill/>
+        </p:spPr>
+        <p:txBody>
+          <a:bodyPr wrap="square">
+            <a:spAutoFit/>
+          </a:bodyPr>
+          <a:lstStyle/>
+          <a:p>
+            <a:pPr algn="l"/>
+            <a:r>
+              <a:rPr sz="900" b="0">
+                <a:solidFill>
+                  <a:srgbClr val="7F8C8D"/>
+                </a:solidFill>
+              </a:rPr>
+              <a:t>※ 他 60 件は JSON アーカイブを参照</a:t>
+            </a:r>
+          </a:p>
+        </p:txBody>
+      </p:sp>
+      <p:sp>
+        <p:nvSpPr>
+          <p:cNvPr id="6" name="TextBox 5"/>
           <p:cNvSpPr txBox="1"/>
           <p:nvPr/>
         </p:nvSpPr>
@@ -6832,7 +7171,7 @@
             <a:r>
               <a:rPr sz="1000">
                 <a:solidFill>
-                  <a:srgbClr val="55C500"/>
+                  <a:srgbClr val="3D99F6"/>
                 </a:solidFill>
               </a:rPr>
               <a:t>▶ </a:t>
@@ -6843,7 +7182,7 @@
                   <a:srgbClr val="2C3E50"/>
                 </a:solidFill>
               </a:rPr>
-              <a:t>情報過多な時代に、そっと背中を押す「AIタロット」が生まれるまで</a:t>
+              <a:t>LLMは長文を本当に読めているのか？「Lost in the Middle」から考えるRAG設計</a:t>
             </a:r>
             <a:r>
               <a:rPr sz="900">
@@ -6851,14 +7190,14 @@
                   <a:srgbClr val="7F8C8D"/>
                 </a:solidFill>
               </a:rPr>
-              <a:t>  (2026-06-14)</a:t>
-            </a:r>
-          </a:p>
-        </p:txBody>
-      </p:sp>
-      <p:sp>
-        <p:nvSpPr>
-          <p:cNvPr id="6" name="TextBox 5"/>
+              <a:t>  (2026-06-13)</a:t>
+            </a:r>
+          </a:p>
+        </p:txBody>
+      </p:sp>
+      <p:sp>
+        <p:nvSpPr>
+          <p:cNvPr id="7" name="TextBox 6"/>
           <p:cNvSpPr txBox="1"/>
           <p:nvPr/>
         </p:nvSpPr>
@@ -6885,14 +7224,14 @@
                 </a:solidFill>
                 <a:hlinkClick r:id="rId2"/>
               </a:rPr>
-              <a:t>https://qiita.com/senle1024/items/e623fc3a350bf4d5fb98</a:t>
-            </a:r>
-          </a:p>
-        </p:txBody>
-      </p:sp>
-      <p:sp>
-        <p:nvSpPr>
-          <p:cNvPr id="7" name="TextBox 6"/>
+              <a:t>https://zenn.dev/japan/articles/73ad921caeb0bd</a:t>
+            </a:r>
+          </a:p>
+        </p:txBody>
+      </p:sp>
+      <p:sp>
+        <p:nvSpPr>
+          <p:cNvPr id="8" name="TextBox 7"/>
           <p:cNvSpPr txBox="1"/>
           <p:nvPr/>
         </p:nvSpPr>
@@ -6918,19 +7257,17 @@
                   <a:srgbClr val="7F8C8D"/>
                 </a:solidFill>
               </a:rPr>
-              <a:t>!Izanami.png
-こんにちは！🙌 
-今回は、そもそも「なぜこのアプリを作ろうと思ったのか？」という開発の裏側をサクッとお話しさせてください。📝
----
-1. なぜ作ろうと思ったのか？：迷える子羊だった私 🐑
-スマホを開けば情報や正論が溢れ、逆</a:t>
-            </a:r>
-          </a:p>
-        </p:txBody>
-      </p:sp>
-      <p:sp>
-        <p:nvSpPr>
-          <p:cNvPr id="8" name="TextBox 7"/>
+              <a:t>LLMアプリケーションを作っていると、次のような発想になりがちです。
+コンテキストウィンドウが大きいモデルを使えば、とりあえず大量のドキュメントを詰め込めばよいのでは？
+しかし、実際にはそう単純ではありません。
+LLMには、長い入力の中に含まれる情報を均等</a:t>
+            </a:r>
+          </a:p>
+        </p:txBody>
+      </p:sp>
+      <p:sp>
+        <p:nvSpPr>
+          <p:cNvPr id="9" name="TextBox 8"/>
           <p:cNvSpPr txBox="1"/>
           <p:nvPr/>
         </p:nvSpPr>
@@ -6953,7 +7290,7 @@
             <a:r>
               <a:rPr sz="1000">
                 <a:solidFill>
-                  <a:srgbClr val="55C500"/>
+                  <a:srgbClr val="3D99F6"/>
                 </a:solidFill>
               </a:rPr>
               <a:t>▶ </a:t>
@@ -6964,7 +7301,7 @@
                   <a:srgbClr val="2C3E50"/>
                 </a:solidFill>
               </a:rPr>
-              <a:t>『バグを直して』で直った。でもコメントは古いままだった</a:t>
+              <a:t>Scale-to-Zero は弱点じゃない——S3 Vectors × OpenSearch Serverless の二段検索 RAG</a:t>
             </a:r>
             <a:r>
               <a:rPr sz="900">
@@ -6972,14 +7309,14 @@
                   <a:srgbClr val="7F8C8D"/>
                 </a:solidFill>
               </a:rPr>
-              <a:t>  (2026-06-14)</a:t>
-            </a:r>
-          </a:p>
-        </p:txBody>
-      </p:sp>
-      <p:sp>
-        <p:nvSpPr>
-          <p:cNvPr id="9" name="TextBox 8"/>
+              <a:t>  (2026-06-13)</a:t>
+            </a:r>
+          </a:p>
+        </p:txBody>
+      </p:sp>
+      <p:sp>
+        <p:nvSpPr>
+          <p:cNvPr id="10" name="TextBox 9"/>
           <p:cNvSpPr txBox="1"/>
           <p:nvPr/>
         </p:nvSpPr>
@@ -7006,14 +7343,14 @@
                 </a:solidFill>
                 <a:hlinkClick r:id="rId3"/>
               </a:rPr>
-              <a:t>https://qiita.com/NeoSoleil/items/a2825269147e76d70763</a:t>
-            </a:r>
-          </a:p>
-        </p:txBody>
-      </p:sp>
-      <p:sp>
-        <p:nvSpPr>
-          <p:cNvPr id="10" name="TextBox 9"/>
+              <a:t>https://zenn.dev/honey_aws/articles/scale-to-zero-dual-vector-rag</a:t>
+            </a:r>
+          </a:p>
+        </p:txBody>
+      </p:sp>
+      <p:sp>
+        <p:nvSpPr>
+          <p:cNvPr id="11" name="TextBox 10"/>
           <p:cNvSpPr txBox="1"/>
           <p:nvPr/>
         </p:nvSpPr>
@@ -7039,15 +7376,15 @@
                   <a:srgbClr val="7F8C8D"/>
                 </a:solidFill>
               </a:rPr>
-              <a:t>AIエージェントは賢いより忠実──だから任せる範囲は人間が決める
-結論から書く。AIコーディングエージェントを使っていて最近いちばん考えているのは「どこまで任せるか」だ。AIが賢いかどうかより、こちらがどこに線を引くか。理由は単純で、AIは賢いというより忠実</a:t>
-            </a:r>
-          </a:p>
-        </p:txBody>
-      </p:sp>
-      <p:sp>
-        <p:nvSpPr>
-          <p:cNvPr id="11" name="TextBox 10"/>
+              <a:t>はじめに
+サーバーレスの「scale-to-zero」（使われていない間はリソースが 0 までスケールして課金が止まる）は、コストの面ではうれしい仕組みです。一方で コールドスタート——アイドル後の初回リクエストで暖機に十数秒かかる——という弱点とセットで語ら</a:t>
+            </a:r>
+          </a:p>
+        </p:txBody>
+      </p:sp>
+      <p:sp>
+        <p:nvSpPr>
+          <p:cNvPr id="12" name="TextBox 11"/>
           <p:cNvSpPr txBox="1"/>
           <p:nvPr/>
         </p:nvSpPr>
@@ -7070,7 +7407,7 @@
             <a:r>
               <a:rPr sz="1000">
                 <a:solidFill>
-                  <a:srgbClr val="55C500"/>
+                  <a:srgbClr val="3D99F6"/>
                 </a:solidFill>
               </a:rPr>
               <a:t>▶ </a:t>
@@ -7081,7 +7418,7 @@
                   <a:srgbClr val="2C3E50"/>
                 </a:solidFill>
               </a:rPr>
-              <a:t>Claude Codeを今すぐ始めたい（インストールから初期設定方法まで）</a:t>
+              <a:t>LLMOps学習でBedrock + Claudeを動かしてみた</a:t>
             </a:r>
             <a:r>
               <a:rPr sz="900">
@@ -7089,14 +7426,14 @@
                   <a:srgbClr val="7F8C8D"/>
                 </a:solidFill>
               </a:rPr>
-              <a:t>  (2026-06-14)</a:t>
-            </a:r>
-          </a:p>
-        </p:txBody>
-      </p:sp>
-      <p:sp>
-        <p:nvSpPr>
-          <p:cNvPr id="12" name="TextBox 11"/>
+              <a:t>  (2026-06-13)</a:t>
+            </a:r>
+          </a:p>
+        </p:txBody>
+      </p:sp>
+      <p:sp>
+        <p:nvSpPr>
+          <p:cNvPr id="13" name="TextBox 12"/>
           <p:cNvSpPr txBox="1"/>
           <p:nvPr/>
         </p:nvSpPr>
@@ -7123,14 +7460,14 @@
                 </a:solidFill>
                 <a:hlinkClick r:id="rId4"/>
               </a:rPr>
-              <a:t>https://qiita.com/NakanakaPierrot/items/d5a309c8e0c096aa1f4d</a:t>
-            </a:r>
-          </a:p>
-        </p:txBody>
-      </p:sp>
-      <p:sp>
-        <p:nvSpPr>
-          <p:cNvPr id="13" name="TextBox 12"/>
+              <a:t>https://zenn.dev/yukika/articles/20260613_bedrock_claude_first_step</a:t>
+            </a:r>
+          </a:p>
+        </p:txBody>
+      </p:sp>
+      <p:sp>
+        <p:nvSpPr>
+          <p:cNvPr id="14" name="TextBox 13"/>
           <p:cNvSpPr txBox="1"/>
           <p:nvPr/>
         </p:nvSpPr>
@@ -7156,17 +7493,18 @@
                   <a:srgbClr val="7F8C8D"/>
                 </a:solidFill>
               </a:rPr>
-              <a:t>Claude Codeのインストールから初期設定方法について記述しておきます。
-参考になれば幸いです。
-準備
-Claudeを利用するには、まずClaudeのサイトに行ってアカウント登録する必要があります。そしてClaude Codeを利用するには、Proプラ</a:t>
-            </a:r>
-          </a:p>
-        </p:txBody>
-      </p:sp>
-      <p:sp>
-        <p:nvSpPr>
-          <p:cNvPr id="14" name="TextBox 13"/>
+              <a:t>はじめに
+こんにちは。
+最近、LLMOpsに興味を持ち始めました。
+Claude Codeはよく触っているのですが、LLMをプログラムから呼び出して使う、みたいなことはやったことがありませんでした。
+Bedrockもまともに触ったことがなかったので、併せて試し</a:t>
+            </a:r>
+          </a:p>
+        </p:txBody>
+      </p:sp>
+      <p:sp>
+        <p:nvSpPr>
+          <p:cNvPr id="15" name="TextBox 14"/>
           <p:cNvSpPr txBox="1"/>
           <p:nvPr/>
         </p:nvSpPr>
@@ -7189,7 +7527,7 @@
             <a:r>
               <a:rPr sz="1000">
                 <a:solidFill>
-                  <a:srgbClr val="55C500"/>
+                  <a:srgbClr val="3D99F6"/>
                 </a:solidFill>
               </a:rPr>
               <a:t>▶ </a:t>
@@ -7200,7 +7538,7 @@
                   <a:srgbClr val="2C3E50"/>
                 </a:solidFill>
               </a:rPr>
-              <a:t>2026/06/14 今日のQiitaトレンド記事をポッドキャストで聴こう！</a:t>
+              <a:t>社内ガイドラインが効かない、情報漏洩は安易な個人AI利用からはじまる</a:t>
             </a:r>
             <a:r>
               <a:rPr sz="900">
@@ -7208,14 +7546,14 @@
                   <a:srgbClr val="7F8C8D"/>
                 </a:solidFill>
               </a:rPr>
-              <a:t>  (2026-06-14)</a:t>
-            </a:r>
-          </a:p>
-        </p:txBody>
-      </p:sp>
-      <p:sp>
-        <p:nvSpPr>
-          <p:cNvPr id="15" name="TextBox 14"/>
+              <a:t>  (2026-06-13)</a:t>
+            </a:r>
+          </a:p>
+        </p:txBody>
+      </p:sp>
+      <p:sp>
+        <p:nvSpPr>
+          <p:cNvPr id="16" name="TextBox 15"/>
           <p:cNvSpPr txBox="1"/>
           <p:nvPr/>
         </p:nvSpPr>
@@ -7242,14 +7580,14 @@
                 </a:solidFill>
                 <a:hlinkClick r:id="rId5"/>
               </a:rPr>
-              <a:t>https://qiita.com/ennagara128/items/d4dcd97dfeca39f884cb</a:t>
-            </a:r>
-          </a:p>
-        </p:txBody>
-      </p:sp>
-      <p:sp>
-        <p:nvSpPr>
-          <p:cNvPr id="16" name="TextBox 15"/>
+              <a:t>https://zenn.dev/syoshida07/articles/baa36522c872e6</a:t>
+            </a:r>
+          </a:p>
+        </p:txBody>
+      </p:sp>
+      <p:sp>
+        <p:nvSpPr>
+          <p:cNvPr id="17" name="TextBox 16"/>
           <p:cNvSpPr txBox="1"/>
           <p:nvPr/>
         </p:nvSpPr>
@@ -7275,19 +7613,15 @@
                   <a:srgbClr val="7F8C8D"/>
                 </a:solidFill>
               </a:rPr>
-              <a:t>前日夜の最新トレンド記事のAIポッドキャストを毎日朝7時に更新しています。
-通勤中などにながら聴きしよう！
-（Qiita投稿は通勤には間に合わないと思われますが）
-フィードバックとか助かりますのでください
-↓こちらから
-&lt;iframe width="56</a:t>
-            </a:r>
-          </a:p>
-        </p:txBody>
-      </p:sp>
-      <p:sp>
-        <p:nvSpPr>
-          <p:cNvPr id="17" name="TextBox 16"/>
+              <a:t>2025〜2026年の政府・公的機関の分析では、企業の生成AIガバナンスは「整備は進んだが、遵守は追いついていない」という評価が共通している。
+特にデジタル庁(2025)と経産省AI事業者ガイドライン(2026)は、ガイドラインは作っただけでは意味がないと明確</a:t>
+            </a:r>
+          </a:p>
+        </p:txBody>
+      </p:sp>
+      <p:sp>
+        <p:nvSpPr>
+          <p:cNvPr id="18" name="TextBox 17"/>
           <p:cNvSpPr txBox="1"/>
           <p:nvPr/>
         </p:nvSpPr>
@@ -7310,7 +7644,7 @@
             <a:r>
               <a:rPr sz="1000">
                 <a:solidFill>
-                  <a:srgbClr val="55C500"/>
+                  <a:srgbClr val="3D99F6"/>
                 </a:solidFill>
               </a:rPr>
               <a:t>▶ </a:t>
@@ -7321,7 +7655,7 @@
                   <a:srgbClr val="2C3E50"/>
                 </a:solidFill>
               </a:rPr>
-              <a:t>2022年に諦めたクイズチャンネルを、Claude Code 5セッションで2026年に動かすまで</a:t>
+              <a:t>多層プロンプトスキーマ（Hierarchical Prompt Schema）</a:t>
             </a:r>
             <a:r>
               <a:rPr sz="900">
@@ -7329,14 +7663,14 @@
                   <a:srgbClr val="7F8C8D"/>
                 </a:solidFill>
               </a:rPr>
-              <a:t>  (2026-06-14)</a:t>
-            </a:r>
-          </a:p>
-        </p:txBody>
-      </p:sp>
-      <p:sp>
-        <p:nvSpPr>
-          <p:cNvPr id="18" name="TextBox 17"/>
+              <a:t>  (2026-06-13)</a:t>
+            </a:r>
+          </a:p>
+        </p:txBody>
+      </p:sp>
+      <p:sp>
+        <p:nvSpPr>
+          <p:cNvPr id="19" name="TextBox 18"/>
           <p:cNvSpPr txBox="1"/>
           <p:nvPr/>
         </p:nvSpPr>
@@ -7363,14 +7697,14 @@
                 </a:solidFill>
                 <a:hlinkClick r:id="rId6"/>
               </a:rPr>
-              <a:t>https://qiita.com/manchan/items/e504bb8f5c3a32ebe5a8</a:t>
-            </a:r>
-          </a:p>
-        </p:txBody>
-      </p:sp>
-      <p:sp>
-        <p:nvSpPr>
-          <p:cNvPr id="19" name="TextBox 18"/>
+              <a:t>https://zenn.dev/yoshi_katakura/articles/3b1952f0096a64</a:t>
+            </a:r>
+          </a:p>
+        </p:txBody>
+      </p:sp>
+      <p:sp>
+        <p:nvSpPr>
+          <p:cNvPr id="20" name="TextBox 19"/>
           <p:cNvSpPr txBox="1"/>
           <p:nvPr/>
         </p:nvSpPr>
@@ -7396,9 +7730,13 @@
                   <a:srgbClr val="7F8C8D"/>
                 </a:solidFill>
               </a:rPr>
-              <a:t>&gt; プロデューサー方式のマルチエージェント分業で、個人開発の動画制作を“録画ボタンを押すだけ”にした話
-はじめに
-個人開発の動画制作を、AIの分業体制で “録画ボタンを押すだけ” にしました。問題作成・画面開発・録画・編集・アップロード・告知——全部AIに</a:t>
+              <a:t>LLMのルール矛盾を自動検出・Mermaid構造化で解消する設計
+LLMのシステムプロンプトは「自然言語で書かれたルール集」です。
+しかし自然言語はコンパイルエラーを出しません。
+「日本語で回答する」
+「英語で話すアインシュタインAI」
+「必ず指名する」
+「最</a:t>
             </a:r>
           </a:p>
         </p:txBody>
@@ -7536,7 +7874,7 @@
                   <a:srgbClr val="FFFFFF"/>
                 </a:solidFill>
               </a:rPr>
-              <a:t>Qiita　記事一覧　(2 / 3)</a:t>
+              <a:t>Qiita　記事一覧　(1 / 3)</a:t>
             </a:r>
           </a:p>
         </p:txBody>
@@ -7577,7 +7915,7 @@
                   <a:srgbClr val="2C3E50"/>
                 </a:solidFill>
               </a:rPr>
-              <a:t>Claude Codeが安全装置のフラグで勝手にモデルを切り替えるのを止める——未文書設定 switchModelsOnFlag（既定true）</a:t>
+              <a:t>Qiita記事7.7万件をClickHouseに入れてAIエージェントに分析させてみた</a:t>
             </a:r>
             <a:r>
               <a:rPr sz="900">
@@ -7619,7 +7957,7 @@
                 </a:solidFill>
                 <a:hlinkClick r:id="rId2"/>
               </a:rPr>
-              <a:t>https://qiita.com/yurukusa/items/74d60654678f8915f50d</a:t>
+              <a:t>https://qiita.com/ktdatascience/items/eff07c425f5b871e819b</a:t>
             </a:r>
           </a:p>
         </p:txBody>
@@ -7652,10 +7990,9 @@
                   <a:srgbClr val="7F8C8D"/>
                 </a:solidFill>
               </a:rPr>
-              <a:t>会話の途中で勝手にモデルが変わる、その正体
-Claude Code を使っていて、こんな経験はないでしょうか。
-- セキュリティ調査やデバッグなど、正当な作業を頼んだのに、会話の途中で応答の雰囲気が急に変わった。
-- 固定したつもりのモデルと違う挙動になり</a:t>
+              <a:t>はじめに
+Qiitaに記事を書いている人なら、一度はこう思ったことがないでしょうか。「自分の記事、どうしたら伸びるんだろう」と。
+私はずっと、これを"なんとなくの肌感"で語るのがイヤでした。「画像は多めがいい」「タイトルは長すぎない方が」——どれも、誰か</a:t>
             </a:r>
           </a:p>
         </p:txBody>
@@ -7696,7 +8033,7 @@
                   <a:srgbClr val="2C3E50"/>
                 </a:solidFill>
               </a:rPr>
-              <a:t>N番煎じでOmnigentをWindows(WSL2)から使ってみる</a:t>
+              <a:t>LLMエージェント設計パターンのコードリーディングで気づいた品質担保の7原則</a:t>
             </a:r>
             <a:r>
               <a:rPr sz="900">
@@ -7738,7 +8075,7 @@
                 </a:solidFill>
                 <a:hlinkClick r:id="rId3"/>
               </a:rPr>
-              <a:t>https://qiita.com/isanakamishiro2/items/eb74a98f942e448ebbb2</a:t>
+              <a:t>https://qiita.com/kuririrn/items/855a1d79848194960f25</a:t>
             </a:r>
           </a:p>
         </p:txBody>
@@ -7771,12 +8108,9 @@
                   <a:srgbClr val="7F8C8D"/>
                 </a:solidFill>
               </a:rPr>
-              <a:t>久しぶりのN番煎じ記事。
-はじめに
-Databricks社がOSSとしてomnigentを発表しました。
-https://omnigent.ai/
-Databricks社公式のblogでも案内されています。
-https://www.databrick</a:t>
+              <a:t>はじめに
+書籍「LangChainとLangGraphによるRAG・AIエージェント［実践］入門」のChapter 12に収録されているエージェントシステムの設計パターンのサンプルコードを読み、動作確認しながら学習しました。
+各パターンのコードを追う中で気</a:t>
             </a:r>
           </a:p>
         </p:txBody>
@@ -7817,7 +8151,7 @@
                   <a:srgbClr val="2C3E50"/>
                 </a:solidFill>
               </a:rPr>
-              <a:t>Claude Codeのセッション再開で$342消えた——トークン爆発を防ぐ2つのhook</a:t>
+              <a:t>情報過多な時代に、そっと背中を押す「AIタロット」が生まれるまで</a:t>
             </a:r>
             <a:r>
               <a:rPr sz="900">
@@ -7859,7 +8193,7 @@
                 </a:solidFill>
                 <a:hlinkClick r:id="rId4"/>
               </a:rPr>
-              <a:t>https://qiita.com/yurukusa/items/7e0b4abcdd13ae322208</a:t>
+              <a:t>https://qiita.com/senle1024/items/e623fc3a350bf4d5fb98</a:t>
             </a:r>
           </a:p>
         </p:txBody>
@@ -7892,10 +8226,12 @@
                   <a:srgbClr val="7F8C8D"/>
                 </a:solidFill>
               </a:rPr>
-              <a:t>セッション再開しただけで$342
-GitHub Issueに衝撃的な報告が上がった。
-38029——ユーザーがセッションを再開しただけで、65万出力トークンが一瞬で消えた。$342。ユーザーは何も入力していない。再開しただけだ。
-「resume my l</a:t>
+              <a:t>!Izanami.png
+こんにちは！🙌 
+今回は、そもそも「なぜこのアプリを作ろうと思ったのか？」という開発の裏側をサクッとお話しさせてください。📝
+---
+1. なぜ作ろうと思ったのか？：迷える子羊だった私 🐑
+スマホを開けば情報や正論が溢れ、逆</a:t>
             </a:r>
           </a:p>
         </p:txBody>
@@ -7936,7 +8272,7 @@
                   <a:srgbClr val="2C3E50"/>
                 </a:solidFill>
               </a:rPr>
-              <a:t>Claude Codeのスキルが自動で発火しない本当の理由——未文書設定 skillListingMaxDescChars(既定1536字)を実機で確かめた</a:t>
+              <a:t>『バグを直して』で直った。でもコメントは古いままだった</a:t>
             </a:r>
             <a:r>
               <a:rPr sz="900">
@@ -7978,7 +8314,7 @@
                 </a:solidFill>
                 <a:hlinkClick r:id="rId5"/>
               </a:rPr>
-              <a:t>https://qiita.com/yurukusa/items/2700b4d67f77220fa618</a:t>
+              <a:t>https://qiita.com/NeoSoleil/items/a2825269147e76d70763</a:t>
             </a:r>
           </a:p>
         </p:txBody>
@@ -8011,9 +8347,8 @@
                   <a:srgbClr val="7F8C8D"/>
                 </a:solidFill>
               </a:rPr>
-              <a:t>「スキルを作ったのに自動で起動しない」の本当の原因
-Claude Code でスキル(Skills)を自作したのに、いざ会話で関連する作業を頼んでも自動で発火しない。とくに日本語で話しかけると起動しない。こういう経験はないでしょうか。
-私(ゆるくさ)も同じ</a:t>
+              <a:t>AIエージェントは賢いより忠実──だから任せる範囲は人間が決める
+結論から書く。AIコーディングエージェントを使っていて最近いちばん考えているのは「どこまで任せるか」だ。AIが賢いかどうかより、こちらがどこに線を引くか。理由は単純で、AIは賢いというより忠実</a:t>
             </a:r>
           </a:p>
         </p:txBody>
@@ -8054,7 +8389,7 @@
                   <a:srgbClr val="2C3E50"/>
                 </a:solidFill>
               </a:rPr>
-              <a:t>AIで対応速度を上げる前に、問い合わせ対応品質を測るシートをGASで作る</a:t>
+              <a:t>Claude Codeを今すぐ始めたい（インストールから初期設定方法まで）</a:t>
             </a:r>
             <a:r>
               <a:rPr sz="900">
@@ -8096,7 +8431,7 @@
                 </a:solidFill>
                 <a:hlinkClick r:id="rId6"/>
               </a:rPr>
-              <a:t>https://qiita.com/Miraigent/items/371c99187f8c92aedbfe</a:t>
+              <a:t>https://qiita.com/NakanakaPierrot/items/d5a309c8e0c096aa1f4d</a:t>
             </a:r>
           </a:p>
         </p:txBody>
@@ -8129,8 +8464,10 @@
                   <a:srgbClr val="7F8C8D"/>
                 </a:solidFill>
               </a:rPr>
-              <a:t>この記事は、問い合わせ対応にAI要約や返信下書きを入れる前に、対応品質を測るための小さな集計シートをGoogleスプレッドシートとGASで作る実装メモです。
-AI APIの呼び出しは扱いません。最初に、返信速度だけでなく、解決率、差し戻し、例外対応、FAQ改</a:t>
+              <a:t>Claude Codeのインストールから初期設定方法について記述しておきます。
+参考になれば幸いです。
+準備
+Claudeを利用するには、まずClaudeのサイトに行ってアカウント登録する必要があります。そしてClaude Codeを利用するには、Proプラ</a:t>
             </a:r>
           </a:p>
         </p:txBody>
@@ -8268,7 +8605,7 @@
                   <a:srgbClr val="FFFFFF"/>
                 </a:solidFill>
               </a:rPr>
-              <a:t>Qiita　記事一覧　(3 / 3)</a:t>
+              <a:t>Qiita　記事一覧　(2 / 3)</a:t>
             </a:r>
           </a:p>
         </p:txBody>
@@ -8276,40 +8613,6 @@
       <p:sp>
         <p:nvSpPr>
           <p:cNvPr id="5" name="TextBox 4"/>
-          <p:cNvSpPr txBox="1"/>
-          <p:nvPr/>
-        </p:nvSpPr>
-        <p:spPr>
-          <a:xfrm>
-            <a:off x="365760" y="6510528"/>
-            <a:ext cx="11430000" cy="320040"/>
-          </a:xfrm>
-          <a:prstGeom prst="rect">
-            <a:avLst/>
-          </a:prstGeom>
-          <a:noFill/>
-        </p:spPr>
-        <p:txBody>
-          <a:bodyPr wrap="square">
-            <a:spAutoFit/>
-          </a:bodyPr>
-          <a:lstStyle/>
-          <a:p>
-            <a:pPr algn="l"/>
-            <a:r>
-              <a:rPr sz="900" b="0">
-                <a:solidFill>
-                  <a:srgbClr val="7F8C8D"/>
-                </a:solidFill>
-              </a:rPr>
-              <a:t>※ 他 117 件は JSON アーカイブを参照</a:t>
-            </a:r>
-          </a:p>
-        </p:txBody>
-      </p:sp>
-      <p:sp>
-        <p:nvSpPr>
-          <p:cNvPr id="6" name="TextBox 5"/>
           <p:cNvSpPr txBox="1"/>
           <p:nvPr/>
         </p:nvSpPr>
@@ -8343,7 +8646,7 @@
                   <a:srgbClr val="2C3E50"/>
                 </a:solidFill>
               </a:rPr>
-              <a:t>RTX 4070 (12GB) で vLLM / SGLang をOOMさせず動かす設定</a:t>
+              <a:t>2026/06/14 今日のQiitaトレンド記事をポッドキャストで聴こう！</a:t>
             </a:r>
             <a:r>
               <a:rPr sz="900">
@@ -8358,7 +8661,7 @@
       </p:sp>
       <p:sp>
         <p:nvSpPr>
-          <p:cNvPr id="7" name="TextBox 6"/>
+          <p:cNvPr id="6" name="TextBox 5"/>
           <p:cNvSpPr txBox="1"/>
           <p:nvPr/>
         </p:nvSpPr>
@@ -8385,14 +8688,14 @@
                 </a:solidFill>
                 <a:hlinkClick r:id="rId2"/>
               </a:rPr>
-              <a:t>https://qiita.com/Marron-chan/items/9c7e6102d1eda28e39b9</a:t>
-            </a:r>
-          </a:p>
-        </p:txBody>
-      </p:sp>
-      <p:sp>
-        <p:nvSpPr>
-          <p:cNvPr id="8" name="TextBox 7"/>
+              <a:t>https://qiita.com/ennagara128/items/d4dcd97dfeca39f884cb</a:t>
+            </a:r>
+          </a:p>
+        </p:txBody>
+      </p:sp>
+      <p:sp>
+        <p:nvSpPr>
+          <p:cNvPr id="7" name="TextBox 6"/>
           <p:cNvSpPr txBox="1"/>
           <p:nvPr/>
         </p:nvSpPr>
@@ -8418,16 +8721,19 @@
                   <a:srgbClr val="7F8C8D"/>
                 </a:solidFill>
               </a:rPr>
-              <a:t>この記事の使い方
-前回（Ollamaが遅い？ 1人なら最速、詰まるのは複数人・RAGから ― vLLM / SGLangを見る判断基準）で「複数人・RAG・低レイテンシで詰まったら vLLM / SGLang を見る」と書きました。
-今回はその続き。12GB</a:t>
-            </a:r>
-          </a:p>
-        </p:txBody>
-      </p:sp>
-      <p:sp>
-        <p:nvSpPr>
-          <p:cNvPr id="9" name="TextBox 8"/>
+              <a:t>前日夜の最新トレンド記事のAIポッドキャストを毎日朝7時に更新しています。
+通勤中などにながら聴きしよう！
+（Qiita投稿は通勤には間に合わないと思われますが）
+フィードバックとか助かりますのでください
+↓こちらから
+&lt;iframe width="56</a:t>
+            </a:r>
+          </a:p>
+        </p:txBody>
+      </p:sp>
+      <p:sp>
+        <p:nvSpPr>
+          <p:cNvPr id="8" name="TextBox 7"/>
           <p:cNvSpPr txBox="1"/>
           <p:nvPr/>
         </p:nvSpPr>
@@ -8461,7 +8767,7 @@
                   <a:srgbClr val="2C3E50"/>
                 </a:solidFill>
               </a:rPr>
-              <a:t>チーム開発でのAPIキー管理、どうしてる？ pydantic-settingsによる型安全・セキュアな一元管理</a:t>
+              <a:t>2022年に諦めたクイズチャンネルを、Claude Code 5セッションで2026年に動かすまで</a:t>
             </a:r>
             <a:r>
               <a:rPr sz="900">
@@ -8476,7 +8782,7 @@
       </p:sp>
       <p:sp>
         <p:nvSpPr>
-          <p:cNvPr id="10" name="TextBox 9"/>
+          <p:cNvPr id="9" name="TextBox 8"/>
           <p:cNvSpPr txBox="1"/>
           <p:nvPr/>
         </p:nvSpPr>
@@ -8503,14 +8809,14 @@
                 </a:solidFill>
                 <a:hlinkClick r:id="rId3"/>
               </a:rPr>
-              <a:t>https://qiita.com/kuririrn/items/1081a10c78fc6bd47fce</a:t>
-            </a:r>
-          </a:p>
-        </p:txBody>
-      </p:sp>
-      <p:sp>
-        <p:nvSpPr>
-          <p:cNvPr id="11" name="TextBox 10"/>
+              <a:t>https://qiita.com/manchan/items/e504bb8f5c3a32ebe5a8</a:t>
+            </a:r>
+          </a:p>
+        </p:txBody>
+      </p:sp>
+      <p:sp>
+        <p:nvSpPr>
+          <p:cNvPr id="10" name="TextBox 9"/>
           <p:cNvSpPr txBox="1"/>
           <p:nvPr/>
         </p:nvSpPr>
@@ -8536,17 +8842,16 @@
                   <a:srgbClr val="7F8C8D"/>
                 </a:solidFill>
               </a:rPr>
-              <a:t>はじめに
-LLMを活用したエージェントシステムをチームで開発していると、OpenAI・Anthropic・Tavilyなど複数サービスのAPIキーを扱う場面が増えてきます。
-このとき、以下のような課題に直面しました。
-- メンバーごとに異なるAPIキーを</a:t>
-            </a:r>
-          </a:p>
-        </p:txBody>
-      </p:sp>
-      <p:sp>
-        <p:nvSpPr>
-          <p:cNvPr id="12" name="TextBox 11"/>
+              <a:t>&gt; プロデューサー方式のマルチエージェント分業で、個人開発の動画制作を“録画ボタンを押すだけ”にした話
+はじめに
+個人開発の動画制作を、AIの分業体制で “録画ボタンを押すだけ” にしました。問題作成・画面開発・録画・編集・アップロード・告知——全部AIに</a:t>
+            </a:r>
+          </a:p>
+        </p:txBody>
+      </p:sp>
+      <p:sp>
+        <p:nvSpPr>
+          <p:cNvPr id="11" name="TextBox 10"/>
           <p:cNvSpPr txBox="1"/>
           <p:nvPr/>
         </p:nvSpPr>
@@ -8580,7 +8885,7 @@
                   <a:srgbClr val="2C3E50"/>
                 </a:solidFill>
               </a:rPr>
-              <a:t>Ollamaが遅い？ 1人なら最速、詰まるのは複数人・RAGから ― vLLM / SGLangを見る判断基準</a:t>
+              <a:t>Claude Codeが安全装置のフラグで勝手にモデルを切り替えるのを止める——未文書設定 switchModelsOnFlag（既定true）</a:t>
             </a:r>
             <a:r>
               <a:rPr sz="900">
@@ -8595,7 +8900,7 @@
       </p:sp>
       <p:sp>
         <p:nvSpPr>
-          <p:cNvPr id="13" name="TextBox 12"/>
+          <p:cNvPr id="12" name="TextBox 11"/>
           <p:cNvSpPr txBox="1"/>
           <p:nvPr/>
         </p:nvSpPr>
@@ -8622,14 +8927,14 @@
                 </a:solidFill>
                 <a:hlinkClick r:id="rId4"/>
               </a:rPr>
-              <a:t>https://qiita.com/Marron-chan/items/ede825e91c740894c197</a:t>
-            </a:r>
-          </a:p>
-        </p:txBody>
-      </p:sp>
-      <p:sp>
-        <p:nvSpPr>
-          <p:cNvPr id="14" name="TextBox 13"/>
+              <a:t>https://qiita.com/yurukusa/items/74d60654678f8915f50d</a:t>
+            </a:r>
+          </a:p>
+        </p:txBody>
+      </p:sp>
+      <p:sp>
+        <p:nvSpPr>
+          <p:cNvPr id="13" name="TextBox 12"/>
           <p:cNvSpPr txBox="1"/>
           <p:nvPr/>
         </p:nvSpPr>
@@ -8655,16 +8960,17 @@
                   <a:srgbClr val="7F8C8D"/>
                 </a:solidFill>
               </a:rPr>
-              <a:t>はじめに
-ローカルLLMを始めるとき、最初に触るのはたいてい Ollama だと思います。
-これだけでモデルが落ちてきて、すぐチャットできる。GPUの設定も、量子化の知識も、サーバの起動オプションもいりません。「とりあえずローカルでLLMを動かす」には</a:t>
-            </a:r>
-          </a:p>
-        </p:txBody>
-      </p:sp>
-      <p:sp>
-        <p:nvSpPr>
-          <p:cNvPr id="15" name="TextBox 14"/>
+              <a:t>会話の途中で勝手にモデルが変わる、その正体
+Claude Code を使っていて、こんな経験はないでしょうか。
+- セキュリティ調査やデバッグなど、正当な作業を頼んだのに、会話の途中で応答の雰囲気が急に変わった。
+- 固定したつもりのモデルと違う挙動になり</a:t>
+            </a:r>
+          </a:p>
+        </p:txBody>
+      </p:sp>
+      <p:sp>
+        <p:nvSpPr>
+          <p:cNvPr id="14" name="TextBox 13"/>
           <p:cNvSpPr txBox="1"/>
           <p:nvPr/>
         </p:nvSpPr>
@@ -8698,7 +9004,7 @@
                   <a:srgbClr val="2C3E50"/>
                 </a:solidFill>
               </a:rPr>
-              <a:t>AI勉強18日目の非エンジニアが、左手デバイスと「絶対開発憲法」でGeminiを専属開発チームにした話</a:t>
+              <a:t>N番煎じでOmnigentをWindows(WSL2)から使ってみる</a:t>
             </a:r>
             <a:r>
               <a:rPr sz="900">
@@ -8713,7 +9019,7 @@
       </p:sp>
       <p:sp>
         <p:nvSpPr>
-          <p:cNvPr id="16" name="TextBox 15"/>
+          <p:cNvPr id="15" name="TextBox 14"/>
           <p:cNvSpPr txBox="1"/>
           <p:nvPr/>
         </p:nvSpPr>
@@ -8740,14 +9046,14 @@
                 </a:solidFill>
                 <a:hlinkClick r:id="rId5"/>
               </a:rPr>
-              <a:t>https://qiita.com/ikifuse/items/b6abc32b678daa00746e</a:t>
-            </a:r>
-          </a:p>
-        </p:txBody>
-      </p:sp>
-      <p:sp>
-        <p:nvSpPr>
-          <p:cNvPr id="17" name="TextBox 16"/>
+              <a:t>https://qiita.com/isanakamishiro2/items/eb74a98f942e448ebbb2</a:t>
+            </a:r>
+          </a:p>
+        </p:txBody>
+      </p:sp>
+      <p:sp>
+        <p:nvSpPr>
+          <p:cNvPr id="16" name="TextBox 15"/>
           <p:cNvSpPr txBox="1"/>
           <p:nvPr/>
         </p:nvSpPr>
@@ -8773,21 +9079,19 @@
                   <a:srgbClr val="7F8C8D"/>
                 </a:solidFill>
               </a:rPr>
-              <a:t>---
-title: 🚀AI勉強18日目の非エンジニアが、左手デバイスと「絶対開発憲法」でGeminiを専属開発チームにした話【Pixel 6a最強説】
-tags:
-  - Python
-  - Gemini
-  - Android
-  - 生産性向上
-  -</a:t>
-            </a:r>
-          </a:p>
-        </p:txBody>
-      </p:sp>
-      <p:sp>
-        <p:nvSpPr>
-          <p:cNvPr id="18" name="TextBox 17"/>
+              <a:t>久しぶりのN番煎じ記事。
+はじめに
+Databricks社がOSSとしてomnigentを発表しました。
+https://omnigent.ai/
+Databricks社公式のblogでも案内されています。
+https://www.databrick</a:t>
+            </a:r>
+          </a:p>
+        </p:txBody>
+      </p:sp>
+      <p:sp>
+        <p:nvSpPr>
+          <p:cNvPr id="17" name="TextBox 16"/>
           <p:cNvSpPr txBox="1"/>
           <p:nvPr/>
         </p:nvSpPr>
@@ -8821,7 +9125,7 @@
                   <a:srgbClr val="2C3E50"/>
                 </a:solidFill>
               </a:rPr>
-              <a:t>フロリダ州のOpenAI提訴をどう読むか：「公式コメント」と「法的な反論予想」を分けて考える</a:t>
+              <a:t>Claude Codeのセッション再開で$342消えた——トークン爆発を防ぐ2つのhook</a:t>
             </a:r>
             <a:r>
               <a:rPr sz="900">
@@ -8836,7 +9140,7 @@
       </p:sp>
       <p:sp>
         <p:nvSpPr>
-          <p:cNvPr id="19" name="TextBox 18"/>
+          <p:cNvPr id="18" name="TextBox 17"/>
           <p:cNvSpPr txBox="1"/>
           <p:nvPr/>
         </p:nvSpPr>
@@ -8863,14 +9167,14 @@
                 </a:solidFill>
                 <a:hlinkClick r:id="rId6"/>
               </a:rPr>
-              <a:t>https://qiita.com/mhamadajp/items/34b95ac1d9126a10ec2e</a:t>
-            </a:r>
-          </a:p>
-        </p:txBody>
-      </p:sp>
-      <p:sp>
-        <p:nvSpPr>
-          <p:cNvPr id="20" name="TextBox 19"/>
+              <a:t>https://qiita.com/yurukusa/items/7e0b4abcdd13ae322208</a:t>
+            </a:r>
+          </a:p>
+        </p:txBody>
+      </p:sp>
+      <p:sp>
+        <p:nvSpPr>
+          <p:cNvPr id="19" name="TextBox 18"/>
           <p:cNvSpPr txBox="1"/>
           <p:nvPr/>
         </p:nvSpPr>
@@ -8896,8 +9200,10 @@
                   <a:srgbClr val="7F8C8D"/>
                 </a:solidFill>
               </a:rPr>
-              <a:t>フロリダ州がOpenAIとサム・アルトマン氏を相手に訴訟を起こした。
-報道だけを見ると、「ChatGPTは危険なのか」「OpenAIは何を隠していたのか」という大きな話に見える。もちろん、それは重要な論点だ。ただ、このニュースを正確に読むには、まず分けて考え</a:t>
+              <a:t>セッション再開しただけで$342
+GitHub Issueに衝撃的な報告が上がった。
+38029——ユーザーがセッションを再開しただけで、65万出力トークンが一瞬で消えた。$342。ユーザーは何も入力していない。再開しただけだ。
+「resume my l</a:t>
             </a:r>
           </a:p>
         </p:txBody>

</xml_diff>